<commit_message>
feat: add HTML product pitch presentation and PPTX generation script
</commit_message>
<xml_diff>
--- a/ClaimGuard_Product_Pitch.pptx
+++ b/ClaimGuard_Product_Pitch.pptx
@@ -5813,8 +5813,8 @@
         </p:nvSpPr>
         <p:spPr>
           <a:xfrm>
-            <a:off x="731520" y="1645920"/>
-            <a:ext cx="5943600" cy="4114800"/>
+            <a:off x="731520" y="1371600"/>
+            <a:ext cx="5943600" cy="4572000"/>
           </a:xfrm>
           <a:prstGeom prst="rect">
             <a:avLst/>
@@ -5828,7 +5828,7 @@
           <a:lstStyle/>
           <a:p>
             <a:pPr>
-              <a:defRPr sz="1200" b="1">
+              <a:defRPr sz="1100" b="1">
                 <a:solidFill>
                   <a:srgbClr val="FDBA74"/>
                 </a:solidFill>
@@ -5836,6 +5836,36 @@
             </a:pPr>
             <a:r>
               <a:t>FINANCIAL VERIFICATION INTELLIGENCE</a:t>
+            </a:r>
+          </a:p>
+          <a:p>
+            <a:pPr>
+              <a:spcBef>
+                <a:spcPts val="1000"/>
+              </a:spcBef>
+              <a:defRPr sz="4600" b="1">
+                <a:solidFill>
+                  <a:srgbClr val="FFFFFF"/>
+                </a:solidFill>
+              </a:defRPr>
+            </a:pPr>
+            <a:r>
+              <a:t>CLAIMGUARD</a:t>
+            </a:r>
+          </a:p>
+          <a:p>
+            <a:pPr>
+              <a:spcBef>
+                <a:spcPts val="800"/>
+              </a:spcBef>
+              <a:defRPr sz="2000" b="1">
+                <a:solidFill>
+                  <a:srgbClr val="F97316"/>
+                </a:solidFill>
+              </a:defRPr>
+            </a:pPr>
+            <a:r>
+              <a:t>Intelligent Expense &amp; Receipt Verification</a:t>
             </a:r>
           </a:p>
           <a:p>
@@ -5843,44 +5873,29 @@
               <a:spcBef>
                 <a:spcPts val="1400"/>
               </a:spcBef>
-              <a:defRPr sz="4800" b="1">
-                <a:solidFill>
-                  <a:srgbClr val="FFFFFF"/>
-                </a:solidFill>
-              </a:defRPr>
-            </a:pPr>
-            <a:r>
-              <a:t>CLAIMGUARD</a:t>
+              <a:defRPr sz="1300">
+                <a:solidFill>
+                  <a:srgbClr val="F8FAFC"/>
+                </a:solidFill>
+              </a:defRPr>
+            </a:pPr>
+            <a:r>
+              <a:t>From field receipt submission to risk-aware managerial decision making. A unified, deterministic compliance platform connecting mobile field staff, cloud OCR, deterministic fraud math, and finance controllers.</a:t>
             </a:r>
           </a:p>
           <a:p>
             <a:pPr>
               <a:spcBef>
-                <a:spcPts val="1000"/>
+                <a:spcPts val="1600"/>
               </a:spcBef>
-              <a:defRPr sz="2200">
-                <a:solidFill>
-                  <a:srgbClr val="F97316"/>
-                </a:solidFill>
-              </a:defRPr>
-            </a:pPr>
-            <a:r>
-              <a:t>Intelligent Expense &amp; Receipt Verification</a:t>
-            </a:r>
-          </a:p>
-          <a:p>
-            <a:pPr>
-              <a:spcBef>
-                <a:spcPts val="1800"/>
-              </a:spcBef>
-              <a:defRPr sz="1400">
-                <a:solidFill>
-                  <a:srgbClr val="F8FAFC"/>
-                </a:solidFill>
-              </a:defRPr>
-            </a:pPr>
-            <a:r>
-              <a:t>From field receipt submission to risk-aware managerial decision making. A unified, deterministic compliance platform for modern distributed organizations.</a:t>
+              <a:defRPr sz="1100" b="1">
+                <a:solidFill>
+                  <a:srgbClr val="FDBA74"/>
+                </a:solidFill>
+              </a:defRPr>
+            </a:pPr>
+            <a:r>
+              <a:t>Verified Reference: Apex Logistics &amp; Field Solutions India Pvt Ltd (APEX-2026)</a:t>
             </a:r>
           </a:p>
         </p:txBody>
@@ -5901,8 +5916,8 @@
         </p:blipFill>
         <p:spPr>
           <a:xfrm>
-            <a:off x="6766560" y="1188720"/>
-            <a:ext cx="4754880" cy="2653887"/>
+            <a:off x="6858000" y="1371600"/>
+            <a:ext cx="4572000" cy="2551814"/>
           </a:xfrm>
           <a:prstGeom prst="rect">
             <a:avLst/>
@@ -5917,7 +5932,7 @@
         </p:nvSpPr>
         <p:spPr>
           <a:xfrm>
-            <a:off x="731520" y="6400800"/>
+            <a:off x="731520" y="6355080"/>
             <a:ext cx="10698480" cy="274320"/>
           </a:xfrm>
           <a:prstGeom prst="rect">
@@ -5940,7 +5955,7 @@
               </a:defRPr>
             </a:pPr>
             <a:r>
-              <a:t>CLAIMGUARD PRODUCT PITCH   |   SLIDE 01 OF 15</a:t>
+              <a:t>CLAIMGUARD PRODUCT PITCH   |   SLIDE 01 OF 15   |   APEX LOGISTICS INDIA PVT LTD</a:t>
             </a:r>
           </a:p>
         </p:txBody>
@@ -6014,8 +6029,8 @@
         </p:nvSpPr>
         <p:spPr>
           <a:xfrm>
-            <a:off x="731520" y="457200"/>
-            <a:ext cx="10698480" cy="365760"/>
+            <a:off x="731520" y="411480"/>
+            <a:ext cx="10698480" cy="320040"/>
           </a:xfrm>
           <a:prstGeom prst="rect">
             <a:avLst/>
@@ -6050,7 +6065,7 @@
         </p:nvSpPr>
         <p:spPr>
           <a:xfrm>
-            <a:off x="731520" y="822960"/>
+            <a:off x="731520" y="731520"/>
             <a:ext cx="10698480" cy="731520"/>
           </a:xfrm>
           <a:prstGeom prst="rect">
@@ -6065,7 +6080,7 @@
           <a:lstStyle/>
           <a:p>
             <a:pPr>
-              <a:defRPr sz="2800" b="1">
+              <a:defRPr sz="2600" b="1">
                 <a:solidFill>
                   <a:srgbClr val="FFFFFF"/>
                 </a:solidFill>
@@ -6086,8 +6101,8 @@
         </p:nvSpPr>
         <p:spPr>
           <a:xfrm>
-            <a:off x="731520" y="1828800"/>
-            <a:ext cx="5120640" cy="4114800"/>
+            <a:off x="731520" y="1691640"/>
+            <a:ext cx="5120640" cy="4297680"/>
           </a:xfrm>
           <a:prstGeom prst="rect">
             <a:avLst/>
@@ -6120,52 +6135,67 @@
           <a:lstStyle/>
           <a:p>
             <a:pPr algn="ctr">
-              <a:defRPr sz="1200" b="1">
+              <a:defRPr sz="1100" b="1">
                 <a:solidFill>
                   <a:srgbClr val="16A34A"/>
                 </a:solidFill>
               </a:defRPr>
             </a:pPr>
             <a:r>
-              <a:t>WHAT AI CAN DO (EXPLANATION LAYER)</a:t>
+              <a:t>WHAT AI DOES &amp;bull; LIVE SYNTHESIS FOR CLM-4471</a:t>
             </a:r>
           </a:p>
           <a:p>
             <a:pPr>
               <a:spcBef>
-                <a:spcPts val="1400"/>
+                <a:spcPts val="800"/>
               </a:spcBef>
-              <a:defRPr sz="1150">
+              <a:defRPr sz="1050">
+                <a:solidFill>
+                  <a:srgbClr val="FFFFFF"/>
+                </a:solidFill>
+              </a:defRPr>
+            </a:pPr>
+            <a:r>
+              <a:t>"Receipt image perceptual hash matches Claim #3902 submitted on 28 Aug 2026 by same employee. Claim amount ₹3,850 exceeds Rahul Kumar's historical category mean (₹1,650) by 2.33x. Manual investigation recommended before payout."</a:t>
+            </a:r>
+          </a:p>
+          <a:p>
+            <a:pPr>
+              <a:spcBef>
+                <a:spcPts val="800"/>
+              </a:spcBef>
+              <a:defRPr sz="1000">
                 <a:solidFill>
                   <a:srgbClr val="F8FAFC"/>
                 </a:solidFill>
               </a:defRPr>
             </a:pPr>
             <a:r>
-              <a:t>+  Synthesizes triggered fraud flags into plain-English summaries</a:t>
+              <a:t>+  Translates raw hash distances &amp; statistical ratios into plain English</a:t>
             </a:r>
           </a:p>
           <a:p>
             <a:pPr>
               <a:spcBef>
-                <a:spcPts val="1400"/>
+                <a:spcPts val="800"/>
               </a:spcBef>
-              <a:defRPr sz="1150">
+              <a:defRPr sz="1000">
                 <a:solidFill>
                   <a:srgbClr val="F8FAFC"/>
                 </a:solidFill>
               </a:defRPr>
             </a:pPr>
             <a:r>
-              <a:t>+  Translates mathematical ratios into actionable manager tips</a:t>
+              <a:t>+  Prompts the manager on exact evidence questions during review</a:t>
             </a:r>
           </a:p>
           <a:p>
             <a:pPr>
               <a:spcBef>
-                <a:spcPts val="1400"/>
+                <a:spcPts val="800"/>
               </a:spcBef>
-              <a:defRPr sz="1150">
+              <a:defRPr sz="1000">
                 <a:solidFill>
                   <a:srgbClr val="F8FAFC"/>
                 </a:solidFill>
@@ -6178,16 +6208,16 @@
           <a:p>
             <a:pPr>
               <a:spcBef>
-                <a:spcPts val="1400"/>
+                <a:spcPts val="800"/>
               </a:spcBef>
-              <a:defRPr sz="1150">
+              <a:defRPr sz="1000">
                 <a:solidFill>
                   <a:srgbClr val="F8FAFC"/>
                 </a:solidFill>
               </a:defRPr>
             </a:pPr>
             <a:r>
-              <a:t>+  Provides contextual explanations to speed up human reviews</a:t>
+              <a:t>+  Accelerates triage so humans make faster, confident decisions</a:t>
             </a:r>
           </a:p>
         </p:txBody>
@@ -6200,8 +6230,8 @@
         </p:nvSpPr>
         <p:spPr>
           <a:xfrm>
-            <a:off x="6217920" y="1828800"/>
-            <a:ext cx="5212080" cy="4114800"/>
+            <a:off x="6217920" y="1691640"/>
+            <a:ext cx="5212080" cy="4297680"/>
           </a:xfrm>
           <a:prstGeom prst="rect">
             <a:avLst/>
@@ -6234,7 +6264,7 @@
           <a:lstStyle/>
           <a:p>
             <a:pPr algn="ctr">
-              <a:defRPr sz="1200" b="1">
+              <a:defRPr sz="1100" b="1">
                 <a:solidFill>
                   <a:srgbClr val="DC2626"/>
                 </a:solidFill>
@@ -6247,61 +6277,76 @@
           <a:p>
             <a:pPr>
               <a:spcBef>
-                <a:spcPts val="1400"/>
+                <a:spcPts val="1200"/>
               </a:spcBef>
-              <a:defRPr sz="1150">
+              <a:defRPr sz="1050">
                 <a:solidFill>
                   <a:srgbClr val="F8FAFC"/>
                 </a:solidFill>
               </a:defRPr>
             </a:pPr>
             <a:r>
-              <a:t>-  Never independently approves or rejects financial claims</a:t>
+              <a:t>-  Zero Autonomous Approvals: AI never approves or disburses funds</a:t>
             </a:r>
           </a:p>
           <a:p>
             <a:pPr>
               <a:spcBef>
-                <a:spcPts val="1400"/>
+                <a:spcPts val="1200"/>
               </a:spcBef>
-              <a:defRPr sz="1150">
+              <a:defRPr sz="1050">
                 <a:solidFill>
                   <a:srgbClr val="F8FAFC"/>
                 </a:solidFill>
               </a:defRPr>
             </a:pPr>
             <a:r>
-              <a:t>-  Never overrides company security policies or spending limits</a:t>
+              <a:t>-  Zero Autonomous Rejections: Rejections require human confirmation</a:t>
             </a:r>
           </a:p>
           <a:p>
             <a:pPr>
               <a:spcBef>
-                <a:spcPts val="1400"/>
+                <a:spcPts val="1200"/>
               </a:spcBef>
-              <a:defRPr sz="1150">
+              <a:defRPr sz="1050">
                 <a:solidFill>
                   <a:srgbClr val="F8FAFC"/>
                 </a:solidFill>
               </a:defRPr>
             </a:pPr>
             <a:r>
-              <a:t>-  Cannot mutate or delete audit log entries in the database</a:t>
+              <a:t>-  No Policy Overrides: AI cannot modify company caps or tax rules</a:t>
             </a:r>
           </a:p>
           <a:p>
             <a:pPr>
               <a:spcBef>
-                <a:spcPts val="1400"/>
+                <a:spcPts val="1200"/>
               </a:spcBef>
-              <a:defRPr sz="1150">
+              <a:defRPr sz="1050">
                 <a:solidFill>
                   <a:srgbClr val="F8FAFC"/>
                 </a:solidFill>
               </a:defRPr>
             </a:pPr>
             <a:r>
-              <a:t>-  Cannot grant organization membership or session credentials</a:t>
+              <a:t>-  Immutable Audit Records: AI cannot touch or mutate database rows</a:t>
+            </a:r>
+          </a:p>
+          <a:p>
+            <a:pPr>
+              <a:spcBef>
+                <a:spcPts val="1200"/>
+              </a:spcBef>
+              <a:defRPr sz="1050">
+                <a:solidFill>
+                  <a:srgbClr val="F8FAFC"/>
+                </a:solidFill>
+              </a:defRPr>
+            </a:pPr>
+            <a:r>
+              <a:t>-  Zero Credential Authority: Cannot grant org access or tokens</a:t>
             </a:r>
           </a:p>
         </p:txBody>
@@ -6314,7 +6359,7 @@
         </p:nvSpPr>
         <p:spPr>
           <a:xfrm>
-            <a:off x="731520" y="6400800"/>
+            <a:off x="731520" y="6355080"/>
             <a:ext cx="10698480" cy="274320"/>
           </a:xfrm>
           <a:prstGeom prst="rect">
@@ -6337,7 +6382,7 @@
               </a:defRPr>
             </a:pPr>
             <a:r>
-              <a:t>CLAIMGUARD PRODUCT PITCH   |   SLIDE 10 OF 15</a:t>
+              <a:t>CLAIMGUARD PRODUCT PITCH   |   SLIDE 10 OF 15   |   APEX LOGISTICS INDIA PVT LTD</a:t>
             </a:r>
           </a:p>
         </p:txBody>
@@ -6411,8 +6456,8 @@
         </p:nvSpPr>
         <p:spPr>
           <a:xfrm>
-            <a:off x="731520" y="457200"/>
-            <a:ext cx="10698480" cy="365760"/>
+            <a:off x="731520" y="411480"/>
+            <a:ext cx="10698480" cy="320040"/>
           </a:xfrm>
           <a:prstGeom prst="rect">
             <a:avLst/>
@@ -6434,7 +6479,7 @@
               </a:defRPr>
             </a:pPr>
             <a:r>
-              <a:t>MULTI-TIER PLATFORM</a:t>
+              <a:t>SCALABLE PLATFORM</a:t>
             </a:r>
           </a:p>
         </p:txBody>
@@ -6447,7 +6492,7 @@
         </p:nvSpPr>
         <p:spPr>
           <a:xfrm>
-            <a:off x="731520" y="822960"/>
+            <a:off x="731520" y="731520"/>
             <a:ext cx="10698480" cy="731520"/>
           </a:xfrm>
           <a:prstGeom prst="rect">
@@ -6462,7 +6507,7 @@
           <a:lstStyle/>
           <a:p>
             <a:pPr>
-              <a:defRPr sz="2800" b="1">
+              <a:defRPr sz="2600" b="1">
                 <a:solidFill>
                   <a:srgbClr val="0F172A"/>
                 </a:solidFill>
@@ -6483,8 +6528,8 @@
         </p:nvSpPr>
         <p:spPr>
           <a:xfrm>
-            <a:off x="731520" y="1828800"/>
-            <a:ext cx="10698480" cy="914400"/>
+            <a:off x="731520" y="1691640"/>
+            <a:ext cx="10698480" cy="960120"/>
           </a:xfrm>
           <a:prstGeom prst="rect">
             <a:avLst/>
@@ -6517,14 +6562,14 @@
           <a:lstStyle/>
           <a:p>
             <a:pPr algn="ctr">
-              <a:defRPr sz="1100" b="1">
+              <a:defRPr sz="1050" b="1">
                 <a:solidFill>
                   <a:srgbClr val="F97316"/>
                 </a:solidFill>
               </a:defRPr>
             </a:pPr>
             <a:r>
-              <a:t>1. CLIENT SURFACES</a:t>
+              <a:t>1. PRESENTATION SURFACES</a:t>
             </a:r>
           </a:p>
           <a:p>
@@ -6532,14 +6577,14 @@
               <a:spcBef>
                 <a:spcPts val="300"/>
               </a:spcBef>
-              <a:defRPr sz="1200">
+              <a:defRPr sz="1150">
                 <a:solidFill>
                   <a:srgbClr val="0F172A"/>
                 </a:solidFill>
               </a:defRPr>
             </a:pPr>
             <a:r>
-              <a:t>Flutter Mobile App (Field Staff)  |  Next.js 15 Web Portal (Finance Managers)</a:t>
+              <a:t>Flutter Mobile App (Field Staff)  |  Next.js 15 Operations Portal (Finance Managers)</a:t>
             </a:r>
           </a:p>
         </p:txBody>
@@ -6552,8 +6597,8 @@
         </p:nvSpPr>
         <p:spPr>
           <a:xfrm>
-            <a:off x="731520" y="2926080"/>
-            <a:ext cx="10698480" cy="914400"/>
+            <a:off x="731520" y="2834640"/>
+            <a:ext cx="10698480" cy="960120"/>
           </a:xfrm>
           <a:prstGeom prst="rect">
             <a:avLst/>
@@ -6586,7 +6631,7 @@
           <a:lstStyle/>
           <a:p>
             <a:pPr algn="ctr">
-              <a:defRPr sz="1100" b="1">
+              <a:defRPr sz="1050" b="1">
                 <a:solidFill>
                   <a:srgbClr val="0F172A"/>
                 </a:solidFill>
@@ -6601,14 +6646,14 @@
               <a:spcBef>
                 <a:spcPts val="300"/>
               </a:spcBef>
-              <a:defRPr sz="1200">
+              <a:defRPr sz="1150">
                 <a:solidFill>
                   <a:srgbClr val="0F172A"/>
                 </a:solidFill>
               </a:defRPr>
             </a:pPr>
             <a:r>
-              <a:t>Fastify REST API  |  JWT Authentication  |  Organization Multi-Tenancy</a:t>
+              <a:t>Fastify REST API  |  JWT Authentication  |  Organization Multi-Tenancy Scoping</a:t>
             </a:r>
           </a:p>
         </p:txBody>
@@ -6621,8 +6666,8 @@
         </p:nvSpPr>
         <p:spPr>
           <a:xfrm>
-            <a:off x="731520" y="4023360"/>
-            <a:ext cx="10698480" cy="914400"/>
+            <a:off x="731520" y="3977639"/>
+            <a:ext cx="10698480" cy="960120"/>
           </a:xfrm>
           <a:prstGeom prst="rect">
             <a:avLst/>
@@ -6655,7 +6700,7 @@
           <a:lstStyle/>
           <a:p>
             <a:pPr algn="ctr">
-              <a:defRPr sz="1100" b="1">
+              <a:defRPr sz="1050" b="1">
                 <a:solidFill>
                   <a:srgbClr val="334155"/>
                 </a:solidFill>
@@ -6670,14 +6715,14 @@
               <a:spcBef>
                 <a:spcPts val="300"/>
               </a:spcBef>
-              <a:defRPr sz="1200">
+              <a:defRPr sz="1150">
                 <a:solidFill>
                   <a:srgbClr val="0F172A"/>
                 </a:solidFill>
               </a:defRPr>
             </a:pPr>
             <a:r>
-              <a:t>Claim Lifecycle  |  Receipt Ingestion  |  Deterministic Fraud Rules  |  Risk Scorer</a:t>
+              <a:t>Receipt Processing  |  Deterministic Fraud Rules  |  0–100 Scorer  |  Audit Committer</a:t>
             </a:r>
           </a:p>
         </p:txBody>
@@ -6691,7 +6736,7 @@
         <p:spPr>
           <a:xfrm>
             <a:off x="731520" y="5120640"/>
-            <a:ext cx="10698480" cy="914400"/>
+            <a:ext cx="10698480" cy="960120"/>
           </a:xfrm>
           <a:prstGeom prst="rect">
             <a:avLst/>
@@ -6724,14 +6769,14 @@
           <a:lstStyle/>
           <a:p>
             <a:pPr algn="ctr">
-              <a:defRPr sz="1100" b="1">
+              <a:defRPr sz="1050" b="1">
                 <a:solidFill>
                   <a:srgbClr val="F97316"/>
                 </a:solidFill>
               </a:defRPr>
             </a:pPr>
             <a:r>
-              <a:t>4. DATA &amp; SERVERLESS CLOUD</a:t>
+              <a:t>4. DATA PERSISTENCE &amp; CLOUD</a:t>
             </a:r>
           </a:p>
           <a:p>
@@ -6739,14 +6784,14 @@
               <a:spcBef>
                 <a:spcPts val="300"/>
               </a:spcBef>
-              <a:defRPr sz="1200">
+              <a:defRPr sz="1150">
                 <a:solidFill>
                   <a:srgbClr val="0F172A"/>
                 </a:solidFill>
               </a:defRPr>
             </a:pPr>
             <a:r>
-              <a:t>Supabase PostgreSQL (RLS, Audit)  |  AWS S3, Textract, Step Functions, Bedrock</a:t>
+              <a:t>Supabase PostgreSQL (RLS, Multi-tenant)  |  AWS S3, Textract, Step Functions, Bedrock</a:t>
             </a:r>
           </a:p>
         </p:txBody>
@@ -6759,7 +6804,7 @@
         </p:nvSpPr>
         <p:spPr>
           <a:xfrm>
-            <a:off x="731520" y="6400800"/>
+            <a:off x="731520" y="6355080"/>
             <a:ext cx="10698480" cy="274320"/>
           </a:xfrm>
           <a:prstGeom prst="rect">
@@ -6782,7 +6827,7 @@
               </a:defRPr>
             </a:pPr>
             <a:r>
-              <a:t>CLAIMGUARD PRODUCT PITCH   |   SLIDE 11 OF 15</a:t>
+              <a:t>CLAIMGUARD PRODUCT PITCH   |   SLIDE 11 OF 15   |   APEX LOGISTICS INDIA PVT LTD</a:t>
             </a:r>
           </a:p>
         </p:txBody>
@@ -6856,8 +6901,8 @@
         </p:nvSpPr>
         <p:spPr>
           <a:xfrm>
-            <a:off x="731520" y="457200"/>
-            <a:ext cx="10698480" cy="365760"/>
+            <a:off x="731520" y="411480"/>
+            <a:ext cx="10698480" cy="320040"/>
           </a:xfrm>
           <a:prstGeom prst="rect">
             <a:avLst/>
@@ -6879,7 +6924,7 @@
               </a:defRPr>
             </a:pPr>
             <a:r>
-              <a:t>RECEIPT LIFECYCLE</a:t>
+              <a:t>RECEIPT LIFECYCLE &amp; LIVE TRACE: CLM-4471</a:t>
             </a:r>
           </a:p>
         </p:txBody>
@@ -6892,7 +6937,7 @@
         </p:nvSpPr>
         <p:spPr>
           <a:xfrm>
-            <a:off x="731520" y="822960"/>
+            <a:off x="731520" y="731520"/>
             <a:ext cx="10698480" cy="731520"/>
           </a:xfrm>
           <a:prstGeom prst="rect">
@@ -6907,7 +6952,7 @@
           <a:lstStyle/>
           <a:p>
             <a:pPr>
-              <a:defRPr sz="2800" b="1">
+              <a:defRPr sz="2600" b="1">
                 <a:solidFill>
                   <a:srgbClr val="FFFFFF"/>
                 </a:solidFill>
@@ -6928,8 +6973,8 @@
         </p:nvSpPr>
         <p:spPr>
           <a:xfrm>
-            <a:off x="731520" y="1828800"/>
-            <a:ext cx="3383280" cy="4114800"/>
+            <a:off x="731520" y="1691640"/>
+            <a:ext cx="3383280" cy="4297680"/>
           </a:xfrm>
           <a:prstGeom prst="rect">
             <a:avLst/>
@@ -6969,7 +7014,7 @@
               </a:defRPr>
             </a:pPr>
             <a:r>
-              <a:t>1. Employee snaps receipt in Flutter app</a:t>
+              <a:t>1. Rahul snaps receipt in Flutter app</a:t>
             </a:r>
           </a:p>
           <a:p>
@@ -6984,7 +7029,7 @@
               </a:defRPr>
             </a:pPr>
             <a:r>
-              <a:t>2. Encrypted image uploaded to Fastify API</a:t>
+              <a:t>2. Fastify API receives encrypted image</a:t>
             </a:r>
           </a:p>
           <a:p>
@@ -6999,7 +7044,7 @@
               </a:defRPr>
             </a:pPr>
             <a:r>
-              <a:t>3. Pending claim record initialized in DB</a:t>
+              <a:t>3. Claim created: CLM-4471 (SUBMITTED)</a:t>
             </a:r>
           </a:p>
           <a:p>
@@ -7014,7 +7059,7 @@
               </a:defRPr>
             </a:pPr>
             <a:r>
-              <a:t>4. Image stored in S3 (KMS encryption)</a:t>
+              <a:t>4. Private S3 bucket KMS upload</a:t>
             </a:r>
           </a:p>
           <a:p>
@@ -7029,7 +7074,7 @@
               </a:defRPr>
             </a:pPr>
             <a:r>
-              <a:t>5. EventBridge triggers AWS Textract OCR</a:t>
+              <a:t>5. EventBridge triggers Textract event</a:t>
             </a:r>
           </a:p>
         </p:txBody>
@@ -7042,8 +7087,8 @@
         </p:nvSpPr>
         <p:spPr>
           <a:xfrm>
-            <a:off x="4389120" y="1828800"/>
-            <a:ext cx="3383280" cy="4114800"/>
+            <a:off x="4389120" y="1691640"/>
+            <a:ext cx="3383280" cy="4297680"/>
           </a:xfrm>
           <a:prstGeom prst="rect">
             <a:avLst/>
@@ -7083,7 +7128,7 @@
               </a:defRPr>
             </a:pPr>
             <a:r>
-              <a:t>6. Textract extracts key-values &amp; lines</a:t>
+              <a:t>6. Textract extracts ₹3,850 &amp; Indian Oil</a:t>
             </a:r>
           </a:p>
           <a:p>
@@ -7098,7 +7143,7 @@
               </a:defRPr>
             </a:pPr>
             <a:r>
-              <a:t>7. Normalizer standardizes date, amount, GSTIN</a:t>
+              <a:t>7. Normalizer standardizes to 2026-09-17</a:t>
             </a:r>
           </a:p>
           <a:p>
@@ -7113,7 +7158,7 @@
               </a:defRPr>
             </a:pPr>
             <a:r>
-              <a:t>8. Deterministic validation checks math/caps</a:t>
+              <a:t>8. GSTIN 29AAACI1681G1ZS verified valid</a:t>
             </a:r>
           </a:p>
           <a:p>
@@ -7128,7 +7173,7 @@
               </a:defRPr>
             </a:pPr>
             <a:r>
-              <a:t>9. Fraud engine checks duplicate hashes</a:t>
+              <a:t>9. Hash collision: matches CLM-3902 (+40)</a:t>
             </a:r>
           </a:p>
           <a:p>
@@ -7143,7 +7188,7 @@
               </a:defRPr>
             </a:pPr>
             <a:r>
-              <a:t>10. Risk engine calculates 0-100 score</a:t>
+              <a:t>10. Anomaly: 2.33x employee baseline (+20)</a:t>
             </a:r>
           </a:p>
         </p:txBody>
@@ -7156,8 +7201,8 @@
         </p:nvSpPr>
         <p:spPr>
           <a:xfrm>
-            <a:off x="8046720" y="1828800"/>
-            <a:ext cx="3383280" cy="4114800"/>
+            <a:off x="8046720" y="1691640"/>
+            <a:ext cx="3383280" cy="4297680"/>
           </a:xfrm>
           <a:prstGeom prst="rect">
             <a:avLst/>
@@ -7197,7 +7242,7 @@
               </a:defRPr>
             </a:pPr>
             <a:r>
-              <a:t>11. AWS Bedrock synthesizes risk narrative</a:t>
+              <a:t>11. Score computed: 65/100 (HIGH Risk)</a:t>
             </a:r>
           </a:p>
           <a:p>
@@ -7212,7 +7257,7 @@
               </a:defRPr>
             </a:pPr>
             <a:r>
-              <a:t>12. All records sync to Supabase with RLS</a:t>
+              <a:t>12. Bedrock generates explanation summary</a:t>
             </a:r>
           </a:p>
           <a:p>
@@ -7227,7 +7272,7 @@
               </a:defRPr>
             </a:pPr>
             <a:r>
-              <a:t>13. Manager receives claim in operations queue</a:t>
+              <a:t>13. Persists to Supabase with RLS security</a:t>
             </a:r>
           </a:p>
           <a:p>
@@ -7242,7 +7287,7 @@
               </a:defRPr>
             </a:pPr>
             <a:r>
-              <a:t>14. Manager approves/rejects with audit note</a:t>
+              <a:t>14. Priya Sharma rejects with audit note</a:t>
             </a:r>
           </a:p>
           <a:p>
@@ -7257,7 +7302,7 @@
               </a:defRPr>
             </a:pPr>
             <a:r>
-              <a:t>15. Employee receives instant phone status sync</a:t>
+              <a:t>15. Phone syncs: Status updated instantly</a:t>
             </a:r>
           </a:p>
         </p:txBody>
@@ -7270,7 +7315,7 @@
         </p:nvSpPr>
         <p:spPr>
           <a:xfrm>
-            <a:off x="731520" y="6400800"/>
+            <a:off x="731520" y="6355080"/>
             <a:ext cx="10698480" cy="274320"/>
           </a:xfrm>
           <a:prstGeom prst="rect">
@@ -7293,7 +7338,7 @@
               </a:defRPr>
             </a:pPr>
             <a:r>
-              <a:t>CLAIMGUARD PRODUCT PITCH   |   SLIDE 12 OF 15</a:t>
+              <a:t>CLAIMGUARD PRODUCT PITCH   |   SLIDE 12 OF 15   |   APEX LOGISTICS INDIA PVT LTD</a:t>
             </a:r>
           </a:p>
         </p:txBody>
@@ -7367,8 +7412,8 @@
         </p:nvSpPr>
         <p:spPr>
           <a:xfrm>
-            <a:off x="731520" y="457200"/>
-            <a:ext cx="10698480" cy="365760"/>
+            <a:off x="731520" y="411480"/>
+            <a:ext cx="10698480" cy="320040"/>
           </a:xfrm>
           <a:prstGeom prst="rect">
             <a:avLst/>
@@ -7390,7 +7435,7 @@
               </a:defRPr>
             </a:pPr>
             <a:r>
-              <a:t>CONTROLLED ONBOARDING</a:t>
+              <a:t>CONTROLLED ONBOARDING &amp; LIVE WORKSPACE</a:t>
             </a:r>
           </a:p>
         </p:txBody>
@@ -7403,7 +7448,7 @@
         </p:nvSpPr>
         <p:spPr>
           <a:xfrm>
-            <a:off x="731520" y="822960"/>
+            <a:off x="731520" y="731520"/>
             <a:ext cx="10698480" cy="731520"/>
           </a:xfrm>
           <a:prstGeom prst="rect">
@@ -7418,7 +7463,7 @@
           <a:lstStyle/>
           <a:p>
             <a:pPr>
-              <a:defRPr sz="2800" b="1">
+              <a:defRPr sz="2600" b="1">
                 <a:solidFill>
                   <a:srgbClr val="0F172A"/>
                 </a:solidFill>
@@ -7447,8 +7492,8 @@
         </p:blipFill>
         <p:spPr>
           <a:xfrm>
-            <a:off x="731520" y="1645920"/>
-            <a:ext cx="5486400" cy="3062177"/>
+            <a:off x="731520" y="1691640"/>
+            <a:ext cx="5120640" cy="2858032"/>
           </a:xfrm>
           <a:prstGeom prst="rect">
             <a:avLst/>
@@ -7463,8 +7508,8 @@
         </p:nvSpPr>
         <p:spPr>
           <a:xfrm>
-            <a:off x="6492240" y="1645920"/>
-            <a:ext cx="4937760" cy="4389120"/>
+            <a:off x="6126480" y="1691640"/>
+            <a:ext cx="5303520" cy="4297680"/>
           </a:xfrm>
           <a:prstGeom prst="rect">
             <a:avLst/>
@@ -7478,14 +7523,14 @@
           <a:lstStyle/>
           <a:p>
             <a:pPr>
-              <a:defRPr sz="1300" b="1">
+              <a:defRPr sz="1200" b="1">
                 <a:solidFill>
                   <a:srgbClr val="0F172A"/>
                 </a:solidFill>
               </a:defRPr>
             </a:pPr>
             <a:r>
-              <a:t>Manager Creates Workspace</a:t>
+              <a:t>Live Active Join Code: CG-7K4P9X</a:t>
             </a:r>
           </a:p>
           <a:p>
@@ -7493,29 +7538,29 @@
               <a:spcBef>
                 <a:spcPts val="200"/>
               </a:spcBef>
-              <a:defRPr sz="1050">
+              <a:defRPr sz="950">
                 <a:solidFill>
                   <a:srgbClr val="334155"/>
                 </a:solidFill>
               </a:defRPr>
             </a:pPr>
             <a:r>
-              <a:t>Manager provisions organization with spending policies and branch parameters in the web portal.</a:t>
+              <a:t>Assigned to Apex Logistics India Pvt Ltd (APEX-2026). Max 100 uses &amp;bull; Valid 30 days.</a:t>
             </a:r>
           </a:p>
           <a:p>
             <a:pPr>
               <a:spcBef>
-                <a:spcPts val="1000"/>
+                <a:spcPts val="900"/>
               </a:spcBef>
-              <a:defRPr sz="1300" b="1">
+              <a:defRPr sz="1200" b="1">
                 <a:solidFill>
                   <a:srgbClr val="0F172A"/>
                 </a:solidFill>
               </a:defRPr>
             </a:pPr>
             <a:r>
-              <a:t>Generates 6-Character Join Code</a:t>
+              <a:t>Manager Creates Workspace</a:t>
             </a:r>
           </a:p>
           <a:p>
@@ -7523,22 +7568,22 @@
               <a:spcBef>
                 <a:spcPts val="200"/>
               </a:spcBef>
-              <a:defRPr sz="1050">
+              <a:defRPr sz="950">
                 <a:solidFill>
                   <a:srgbClr val="334155"/>
                 </a:solidFill>
               </a:defRPr>
             </a:pPr>
             <a:r>
-              <a:t>Temporary alpha-numeric code (e.g. 'CG-7842') generated with short TTL and role assignment.</a:t>
+              <a:t>Priya Sharma configures spending policies (Fuel ₹5k cap, Meals ₹1.2k cap) and department roles.</a:t>
             </a:r>
           </a:p>
           <a:p>
             <a:pPr>
               <a:spcBef>
-                <a:spcPts val="1000"/>
+                <a:spcPts val="900"/>
               </a:spcBef>
-              <a:defRPr sz="1300" b="1">
+              <a:defRPr sz="1200" b="1">
                 <a:solidFill>
                   <a:srgbClr val="0F172A"/>
                 </a:solidFill>
@@ -7553,29 +7598,29 @@
               <a:spcBef>
                 <a:spcPts val="200"/>
               </a:spcBef>
-              <a:defRPr sz="1050">
+              <a:defRPr sz="950">
                 <a:solidFill>
                   <a:srgbClr val="334155"/>
                 </a:solidFill>
               </a:defRPr>
             </a:pPr>
             <a:r>
-              <a:t>Field staff enter the code in the mobile app. Device is cryptographically bound to the company.</a:t>
+              <a:t>Rahul Kumar enters code CG-7K4P9X once. Device is cryptographically bound to Apex Logistics.</a:t>
             </a:r>
           </a:p>
           <a:p>
             <a:pPr>
               <a:spcBef>
-                <a:spcPts val="1000"/>
+                <a:spcPts val="900"/>
               </a:spcBef>
-              <a:defRPr sz="1300" b="1">
+              <a:defRPr sz="1200" b="1">
                 <a:solidFill>
                   <a:srgbClr val="0F172A"/>
                 </a:solidFill>
               </a:defRPr>
             </a:pPr>
             <a:r>
-              <a:t>No Social Login Lock-In</a:t>
+              <a:t>No Social Login Dependency</a:t>
             </a:r>
           </a:p>
           <a:p>
@@ -7583,22 +7628,22 @@
               <a:spcBef>
                 <a:spcPts val="200"/>
               </a:spcBef>
-              <a:defRPr sz="1050">
+              <a:defRPr sz="950">
                 <a:solidFill>
                   <a:srgbClr val="334155"/>
                 </a:solidFill>
               </a:defRPr>
             </a:pPr>
             <a:r>
-              <a:t>No Google accounts, corporate emails, or complex passwords required for drivers and field crew.</a:t>
+              <a:t>No corporate Google accounts or passwords required for field technicians. Paired via device session.</a:t>
             </a:r>
           </a:p>
           <a:p>
             <a:pPr>
               <a:spcBef>
-                <a:spcPts val="1000"/>
+                <a:spcPts val="900"/>
               </a:spcBef>
-              <a:defRPr sz="1300" b="1">
+              <a:defRPr sz="1200" b="1">
                 <a:solidFill>
                   <a:srgbClr val="0F172A"/>
                 </a:solidFill>
@@ -7613,14 +7658,14 @@
               <a:spcBef>
                 <a:spcPts val="200"/>
               </a:spcBef>
-              <a:defRPr sz="1050">
+              <a:defRPr sz="950">
                 <a:solidFill>
                   <a:srgbClr val="334155"/>
                 </a:solidFill>
               </a:defRPr>
             </a:pPr>
             <a:r>
-              <a:t>Backend validates code, creates membership, and issues scoped access tokens stored in device keychain.</a:t>
+              <a:t>Backend validates code, provisions membership, and issues scoped access tokens stored in keychain.</a:t>
             </a:r>
           </a:p>
         </p:txBody>
@@ -7633,7 +7678,7 @@
         </p:nvSpPr>
         <p:spPr>
           <a:xfrm>
-            <a:off x="731520" y="6400800"/>
+            <a:off x="731520" y="6355080"/>
             <a:ext cx="10698480" cy="274320"/>
           </a:xfrm>
           <a:prstGeom prst="rect">
@@ -7656,7 +7701,7 @@
               </a:defRPr>
             </a:pPr>
             <a:r>
-              <a:t>CLAIMGUARD PRODUCT PITCH   |   SLIDE 13 OF 15</a:t>
+              <a:t>CLAIMGUARD PRODUCT PITCH   |   SLIDE 13 OF 15   |   APEX LOGISTICS INDIA PVT LTD</a:t>
             </a:r>
           </a:p>
         </p:txBody>
@@ -7730,8 +7775,8 @@
         </p:nvSpPr>
         <p:spPr>
           <a:xfrm>
-            <a:off x="731520" y="457200"/>
-            <a:ext cx="10698480" cy="365760"/>
+            <a:off x="731520" y="411480"/>
+            <a:ext cx="10698480" cy="320040"/>
           </a:xfrm>
           <a:prstGeom prst="rect">
             <a:avLst/>
@@ -7766,7 +7811,7 @@
         </p:nvSpPr>
         <p:spPr>
           <a:xfrm>
-            <a:off x="731520" y="822960"/>
+            <a:off x="731520" y="731520"/>
             <a:ext cx="10698480" cy="731520"/>
           </a:xfrm>
           <a:prstGeom prst="rect">
@@ -7781,7 +7826,7 @@
           <a:lstStyle/>
           <a:p>
             <a:pPr>
-              <a:defRPr sz="2800" b="1">
+              <a:defRPr sz="2600" b="1">
                 <a:solidFill>
                   <a:srgbClr val="0F172A"/>
                 </a:solidFill>
@@ -7802,8 +7847,8 @@
         </p:nvSpPr>
         <p:spPr>
           <a:xfrm>
-            <a:off x="731520" y="1828800"/>
-            <a:ext cx="5212080" cy="2011680"/>
+            <a:off x="731520" y="1691640"/>
+            <a:ext cx="5212080" cy="2057400"/>
           </a:xfrm>
           <a:prstGeom prst="roundRect">
             <a:avLst/>
@@ -7832,11 +7877,11 @@
           </a:fontRef>
         </p:style>
         <p:txBody>
-          <a:bodyPr rtlCol="0" anchor="ctr" wrap="square" lIns="274320" rIns="274320" tIns="274320"/>
+          <a:bodyPr rtlCol="0" anchor="ctr" wrap="square" lIns="228600" rIns="228600" tIns="228600"/>
           <a:lstStyle/>
           <a:p>
             <a:pPr algn="ctr">
-              <a:defRPr sz="1500" b="1">
+              <a:defRPr sz="1400" b="1">
                 <a:solidFill>
                   <a:srgbClr val="F97316"/>
                 </a:solidFill>
@@ -7849,16 +7894,16 @@
           <a:p>
             <a:pPr>
               <a:spcBef>
-                <a:spcPts val="800"/>
+                <a:spcPts val="600"/>
               </a:spcBef>
-              <a:defRPr sz="1100">
+              <a:defRPr sz="1050">
                 <a:solidFill>
                   <a:srgbClr val="334155"/>
                 </a:solidFill>
               </a:defRPr>
             </a:pPr>
             <a:r>
-              <a:t>Automated OCR, math checks &amp; GSTIN validation free managers from tedious receipt auditing.</a:t>
+              <a:t>Automated Textract data entry and deterministic arithmetic checks eliminate repetitive receipt auditing.</a:t>
             </a:r>
           </a:p>
         </p:txBody>
@@ -7871,8 +7916,8 @@
         </p:nvSpPr>
         <p:spPr>
           <a:xfrm>
-            <a:off x="6217920" y="1828800"/>
-            <a:ext cx="5212080" cy="2011680"/>
+            <a:off x="6217920" y="1691640"/>
+            <a:ext cx="5212080" cy="2057400"/>
           </a:xfrm>
           <a:prstGeom prst="roundRect">
             <a:avLst/>
@@ -7901,11 +7946,11 @@
           </a:fontRef>
         </p:style>
         <p:txBody>
-          <a:bodyPr rtlCol="0" anchor="ctr" wrap="square" lIns="274320" rIns="274320" tIns="274320"/>
+          <a:bodyPr rtlCol="0" anchor="ctr" wrap="square" lIns="228600" rIns="228600" tIns="228600"/>
           <a:lstStyle/>
           <a:p>
             <a:pPr algn="ctr">
-              <a:defRPr sz="1500" b="1">
+              <a:defRPr sz="1400" b="1">
                 <a:solidFill>
                   <a:srgbClr val="F97316"/>
                 </a:solidFill>
@@ -7918,16 +7963,16 @@
           <a:p>
             <a:pPr>
               <a:spcBef>
-                <a:spcPts val="800"/>
+                <a:spcPts val="600"/>
               </a:spcBef>
-              <a:defRPr sz="1100">
+              <a:defRPr sz="1050">
                 <a:solidFill>
                   <a:srgbClr val="334155"/>
                 </a:solidFill>
               </a:defRPr>
             </a:pPr>
             <a:r>
-              <a:t>Field staff receive reimbursement decisions in days or hours instead of weeks, boosting morale.</a:t>
+              <a:t>Field employees receive reimbursement approvals in hours or days instead of weeks, boosting workforce morale.</a:t>
             </a:r>
           </a:p>
         </p:txBody>
@@ -7940,8 +7985,8 @@
         </p:nvSpPr>
         <p:spPr>
           <a:xfrm>
-            <a:off x="731520" y="4023360"/>
-            <a:ext cx="5212080" cy="2011680"/>
+            <a:off x="731520" y="3977639"/>
+            <a:ext cx="5212080" cy="2057400"/>
           </a:xfrm>
           <a:prstGeom prst="roundRect">
             <a:avLst/>
@@ -7970,11 +8015,11 @@
           </a:fontRef>
         </p:style>
         <p:txBody>
-          <a:bodyPr rtlCol="0" anchor="ctr" wrap="square" lIns="274320" rIns="274320" tIns="274320"/>
+          <a:bodyPr rtlCol="0" anchor="ctr" wrap="square" lIns="228600" rIns="228600" tIns="228600"/>
           <a:lstStyle/>
           <a:p>
             <a:pPr algn="ctr">
-              <a:defRPr sz="1500" b="1">
+              <a:defRPr sz="1400" b="1">
                 <a:solidFill>
                   <a:srgbClr val="F97316"/>
                 </a:solidFill>
@@ -7987,16 +8032,16 @@
           <a:p>
             <a:pPr>
               <a:spcBef>
-                <a:spcPts val="800"/>
+                <a:spcPts val="600"/>
               </a:spcBef>
-              <a:defRPr sz="1100">
+              <a:defRPr sz="1050">
                 <a:solidFill>
                   <a:srgbClr val="334155"/>
                 </a:solidFill>
               </a:defRPr>
             </a:pPr>
             <a:r>
-              <a:t>Duplicate hashes, historical spending spikes &amp; fake tax IDs flagged before payouts are disbursed.</a:t>
+              <a:t>Perceptual duplicate hashes, historical spikes, and invalid GSTINs are caught before company funds are disbursed.</a:t>
             </a:r>
           </a:p>
         </p:txBody>
@@ -8009,8 +8054,8 @@
         </p:nvSpPr>
         <p:spPr>
           <a:xfrm>
-            <a:off x="6217920" y="4023360"/>
-            <a:ext cx="5212080" cy="2011680"/>
+            <a:off x="6217920" y="3977639"/>
+            <a:ext cx="5212080" cy="2057400"/>
           </a:xfrm>
           <a:prstGeom prst="roundRect">
             <a:avLst/>
@@ -8039,11 +8084,11 @@
           </a:fontRef>
         </p:style>
         <p:txBody>
-          <a:bodyPr rtlCol="0" anchor="ctr" wrap="square" lIns="274320" rIns="274320" tIns="274320"/>
+          <a:bodyPr rtlCol="0" anchor="ctr" wrap="square" lIns="228600" rIns="228600" tIns="228600"/>
           <a:lstStyle/>
           <a:p>
             <a:pPr algn="ctr">
-              <a:defRPr sz="1500" b="1">
+              <a:defRPr sz="1400" b="1">
                 <a:solidFill>
                   <a:srgbClr val="F97316"/>
                 </a:solidFill>
@@ -8056,16 +8101,16 @@
           <a:p>
             <a:pPr>
               <a:spcBef>
-                <a:spcPts val="800"/>
+                <a:spcPts val="600"/>
               </a:spcBef>
-              <a:defRPr sz="1100">
+              <a:defRPr sz="1050">
                 <a:solidFill>
                   <a:srgbClr val="334155"/>
                 </a:solidFill>
               </a:defRPr>
             </a:pPr>
             <a:r>
-              <a:t>Unified audit trail and real-time dashboard provide complete oversight across all regional branches.</a:t>
+              <a:t>Unified PostgreSQL audit trail provides complete compliance oversight across all regional branches and field units.</a:t>
             </a:r>
           </a:p>
         </p:txBody>
@@ -8078,7 +8123,7 @@
         </p:nvSpPr>
         <p:spPr>
           <a:xfrm>
-            <a:off x="731520" y="6400800"/>
+            <a:off x="731520" y="6355080"/>
             <a:ext cx="10698480" cy="274320"/>
           </a:xfrm>
           <a:prstGeom prst="rect">
@@ -8101,7 +8146,7 @@
               </a:defRPr>
             </a:pPr>
             <a:r>
-              <a:t>CLAIMGUARD PRODUCT PITCH   |   SLIDE 14 OF 15</a:t>
+              <a:t>CLAIMGUARD PRODUCT PITCH   |   SLIDE 14 OF 15   |   APEX LOGISTICS INDIA PVT LTD</a:t>
             </a:r>
           </a:p>
         </p:txBody>
@@ -8175,8 +8220,8 @@
         </p:nvSpPr>
         <p:spPr>
           <a:xfrm>
-            <a:off x="731520" y="457200"/>
-            <a:ext cx="10698480" cy="365760"/>
+            <a:off x="731520" y="411480"/>
+            <a:ext cx="10698480" cy="320040"/>
           </a:xfrm>
           <a:prstGeom prst="rect">
             <a:avLst/>
@@ -8211,7 +8256,7 @@
         </p:nvSpPr>
         <p:spPr>
           <a:xfrm>
-            <a:off x="731520" y="822960"/>
+            <a:off x="731520" y="731520"/>
             <a:ext cx="10698480" cy="731520"/>
           </a:xfrm>
           <a:prstGeom prst="rect">
@@ -8226,7 +8271,7 @@
           <a:lstStyle/>
           <a:p>
             <a:pPr>
-              <a:defRPr sz="2800" b="1">
+              <a:defRPr sz="2600" b="1">
                 <a:solidFill>
                   <a:srgbClr val="FFFFFF"/>
                 </a:solidFill>
@@ -8247,8 +8292,8 @@
         </p:nvSpPr>
         <p:spPr>
           <a:xfrm>
-            <a:off x="731520" y="1920240"/>
-            <a:ext cx="2057400" cy="3931920"/>
+            <a:off x="731520" y="1691640"/>
+            <a:ext cx="2057400" cy="4297680"/>
           </a:xfrm>
           <a:prstGeom prst="rect">
             <a:avLst/>
@@ -8281,14 +8326,14 @@
           <a:lstStyle/>
           <a:p>
             <a:pPr algn="ctr">
-              <a:defRPr sz="1100" b="1">
+              <a:defRPr sz="1000" b="1">
                 <a:solidFill>
                   <a:srgbClr val="16A34A"/>
                 </a:solidFill>
               </a:defRPr>
             </a:pPr>
             <a:r>
-              <a:t>PHASE 1 (CURRENT)</a:t>
+              <a:t>PHASE 1 (ACTIVE)</a:t>
             </a:r>
           </a:p>
           <a:p>
@@ -8296,7 +8341,7 @@
               <a:spcBef>
                 <a:spcPts val="800"/>
               </a:spcBef>
-              <a:defRPr sz="1000">
+              <a:defRPr sz="950">
                 <a:solidFill>
                   <a:srgbClr val="F8FAFC"/>
                 </a:solidFill>
@@ -8316,8 +8361,8 @@
         </p:nvSpPr>
         <p:spPr>
           <a:xfrm>
-            <a:off x="2926080" y="1920240"/>
-            <a:ext cx="2057400" cy="3931920"/>
+            <a:off x="2926080" y="1691640"/>
+            <a:ext cx="2057400" cy="4297680"/>
           </a:xfrm>
           <a:prstGeom prst="rect">
             <a:avLst/>
@@ -8350,7 +8395,7 @@
           <a:lstStyle/>
           <a:p>
             <a:pPr algn="ctr">
-              <a:defRPr sz="1100" b="1">
+              <a:defRPr sz="1000" b="1">
                 <a:solidFill>
                   <a:srgbClr val="FDBA74"/>
                 </a:solidFill>
@@ -8365,14 +8410,14 @@
               <a:spcBef>
                 <a:spcPts val="800"/>
               </a:spcBef>
-              <a:defRPr sz="1000">
+              <a:defRPr sz="950">
                 <a:solidFill>
                   <a:srgbClr val="F8FAFC"/>
                 </a:solidFill>
               </a:defRPr>
             </a:pPr>
             <a:r>
-              <a:t>Advanced risk intelligence with 90-day rolling behavioral baselines and peer group clustering.</a:t>
+              <a:t>Advanced risk intelligence with 90-day rolling behavioral baselines and peer clustering.</a:t>
             </a:r>
           </a:p>
         </p:txBody>
@@ -8385,8 +8430,8 @@
         </p:nvSpPr>
         <p:spPr>
           <a:xfrm>
-            <a:off x="5120640" y="1920240"/>
-            <a:ext cx="2057400" cy="3931920"/>
+            <a:off x="5120640" y="1691640"/>
+            <a:ext cx="2057400" cy="4297680"/>
           </a:xfrm>
           <a:prstGeom prst="rect">
             <a:avLst/>
@@ -8419,7 +8464,7 @@
           <a:lstStyle/>
           <a:p>
             <a:pPr algn="ctr">
-              <a:defRPr sz="1100" b="1">
+              <a:defRPr sz="1000" b="1">
                 <a:solidFill>
                   <a:srgbClr val="FDBA74"/>
                 </a:solidFill>
@@ -8434,7 +8479,7 @@
               <a:spcBef>
                 <a:spcPts val="800"/>
               </a:spcBef>
-              <a:defRPr sz="1000">
+              <a:defRPr sz="950">
                 <a:solidFill>
                   <a:srgbClr val="F8FAFC"/>
                 </a:solidFill>
@@ -8454,8 +8499,8 @@
         </p:nvSpPr>
         <p:spPr>
           <a:xfrm>
-            <a:off x="7315200" y="1920240"/>
-            <a:ext cx="2057400" cy="3931920"/>
+            <a:off x="7315200" y="1691640"/>
+            <a:ext cx="2057400" cy="4297680"/>
           </a:xfrm>
           <a:prstGeom prst="rect">
             <a:avLst/>
@@ -8488,14 +8533,14 @@
           <a:lstStyle/>
           <a:p>
             <a:pPr algn="ctr">
-              <a:defRPr sz="1100" b="1">
+              <a:defRPr sz="1000" b="1">
                 <a:solidFill>
                   <a:srgbClr val="64748B"/>
                 </a:solidFill>
               </a:defRPr>
             </a:pPr>
             <a:r>
-              <a:t>PHASE 4 (MESSAGING)</a:t>
+              <a:t>PHASE 4 (FUTURE)</a:t>
             </a:r>
           </a:p>
           <a:p>
@@ -8503,7 +8548,7 @@
               <a:spcBef>
                 <a:spcPts val="800"/>
               </a:spcBef>
-              <a:defRPr sz="1000">
+              <a:defRPr sz="950">
                 <a:solidFill>
                   <a:srgbClr val="F8FAFC"/>
                 </a:solidFill>
@@ -8523,8 +8568,8 @@
         </p:nvSpPr>
         <p:spPr>
           <a:xfrm>
-            <a:off x="9509760" y="1920240"/>
-            <a:ext cx="2057400" cy="3931920"/>
+            <a:off x="9509760" y="1691640"/>
+            <a:ext cx="2057400" cy="4297680"/>
           </a:xfrm>
           <a:prstGeom prst="rect">
             <a:avLst/>
@@ -8557,14 +8602,14 @@
           <a:lstStyle/>
           <a:p>
             <a:pPr algn="ctr">
-              <a:defRPr sz="1100" b="1">
+              <a:defRPr sz="1000" b="1">
                 <a:solidFill>
                   <a:srgbClr val="64748B"/>
                 </a:solidFill>
               </a:defRPr>
             </a:pPr>
             <a:r>
-              <a:t>PHASE 5 (ERP CONNECTORS)</a:t>
+              <a:t>PHASE 5 (FUTURE)</a:t>
             </a:r>
           </a:p>
           <a:p>
@@ -8572,7 +8617,7 @@
               <a:spcBef>
                 <a:spcPts val="800"/>
               </a:spcBef>
-              <a:defRPr sz="1000">
+              <a:defRPr sz="950">
                 <a:solidFill>
                   <a:srgbClr val="F8FAFC"/>
                 </a:solidFill>
@@ -8592,7 +8637,7 @@
         </p:nvSpPr>
         <p:spPr>
           <a:xfrm>
-            <a:off x="731520" y="6400800"/>
+            <a:off x="731520" y="6355080"/>
             <a:ext cx="10698480" cy="274320"/>
           </a:xfrm>
           <a:prstGeom prst="rect">
@@ -8615,7 +8660,7 @@
               </a:defRPr>
             </a:pPr>
             <a:r>
-              <a:t>CLAIMGUARD PRODUCT PITCH   |   SLIDE 15 OF 15</a:t>
+              <a:t>CLAIMGUARD PRODUCT PITCH   |   SLIDE 15 OF 15   |   APEX LOGISTICS INDIA PVT LTD</a:t>
             </a:r>
           </a:p>
         </p:txBody>
@@ -8689,8 +8734,8 @@
         </p:nvSpPr>
         <p:spPr>
           <a:xfrm>
-            <a:off x="731520" y="457200"/>
-            <a:ext cx="10698480" cy="365760"/>
+            <a:off x="731520" y="411480"/>
+            <a:ext cx="10698480" cy="320040"/>
           </a:xfrm>
           <a:prstGeom prst="rect">
             <a:avLst/>
@@ -8725,7 +8770,7 @@
         </p:nvSpPr>
         <p:spPr>
           <a:xfrm>
-            <a:off x="731520" y="822960"/>
+            <a:off x="731520" y="731520"/>
             <a:ext cx="10698480" cy="731520"/>
           </a:xfrm>
           <a:prstGeom prst="rect">
@@ -8740,7 +8785,7 @@
           <a:lstStyle/>
           <a:p>
             <a:pPr>
-              <a:defRPr sz="2800" b="1">
+              <a:defRPr sz="2600" b="1">
                 <a:solidFill>
                   <a:srgbClr val="0F172A"/>
                 </a:solidFill>
@@ -8761,8 +8806,8 @@
         </p:nvSpPr>
         <p:spPr>
           <a:xfrm>
-            <a:off x="731520" y="1828800"/>
-            <a:ext cx="2468880" cy="4114800"/>
+            <a:off x="731520" y="1691640"/>
+            <a:ext cx="2514600" cy="4297680"/>
           </a:xfrm>
           <a:prstGeom prst="roundRect">
             <a:avLst/>
@@ -8810,7 +8855,7 @@
               <a:spcBef>
                 <a:spcPts val="800"/>
               </a:spcBef>
-              <a:defRPr sz="1500" b="1">
+              <a:defRPr sz="1400" b="1">
                 <a:solidFill>
                   <a:srgbClr val="0F172A"/>
                 </a:solidFill>
@@ -8832,7 +8877,7 @@
               </a:defRPr>
             </a:pPr>
             <a:r>
-              <a:t>Field staff collect crumpled paper receipts or forward random photos over WhatsApp threads days or weeks later.</a:t>
+              <a:t>Field employees collect thermal slips in pockets or forward unstructured WhatsApp photos weeks after travel ends.</a:t>
             </a:r>
           </a:p>
         </p:txBody>
@@ -8845,8 +8890,8 @@
         </p:nvSpPr>
         <p:spPr>
           <a:xfrm>
-            <a:off x="3429000" y="1828800"/>
-            <a:ext cx="2468880" cy="4114800"/>
+            <a:off x="3429000" y="1691640"/>
+            <a:ext cx="2514600" cy="4297680"/>
           </a:xfrm>
           <a:prstGeom prst="roundRect">
             <a:avLst/>
@@ -8886,7 +8931,7 @@
               </a:defRPr>
             </a:pPr>
             <a:r>
-              <a:t>HIGH ADMINISTRATIVE COST</a:t>
+              <a:t>HIGH ADMIN COST</a:t>
             </a:r>
           </a:p>
           <a:p>
@@ -8894,7 +8939,7 @@
               <a:spcBef>
                 <a:spcPts val="800"/>
               </a:spcBef>
-              <a:defRPr sz="1500" b="1">
+              <a:defRPr sz="1400" b="1">
                 <a:solidFill>
                   <a:srgbClr val="0F172A"/>
                 </a:solidFill>
@@ -8916,7 +8961,7 @@
               </a:defRPr>
             </a:pPr>
             <a:r>
-              <a:t>Finance managers manually re-type amounts, vendors, and dates into spreadsheets, struggling with faded ink.</a:t>
+              <a:t>Controllers spend 5–10 minutes per receipt deciphering faded thermal print and re-typing totals into spreadsheets.</a:t>
             </a:r>
           </a:p>
         </p:txBody>
@@ -8929,8 +8974,8 @@
         </p:nvSpPr>
         <p:spPr>
           <a:xfrm>
-            <a:off x="6126480" y="1828800"/>
-            <a:ext cx="2468880" cy="4114800"/>
+            <a:off x="6126480" y="1691640"/>
+            <a:ext cx="2514600" cy="4297680"/>
           </a:xfrm>
           <a:prstGeom prst="roundRect">
             <a:avLst/>
@@ -8970,7 +9015,7 @@
               </a:defRPr>
             </a:pPr>
             <a:r>
-              <a:t>SILENT POLICY LEAKAGE</a:t>
+              <a:t>SILENT LEAKAGE</a:t>
             </a:r>
           </a:p>
           <a:p>
@@ -8978,7 +9023,7 @@
               <a:spcBef>
                 <a:spcPts val="800"/>
               </a:spcBef>
-              <a:defRPr sz="1500" b="1">
+              <a:defRPr sz="1400" b="1">
                 <a:solidFill>
                   <a:srgbClr val="0F172A"/>
                 </a:solidFill>
@@ -9000,7 +9045,7 @@
               </a:defRPr>
             </a:pPr>
             <a:r>
-              <a:t>Humans cannot reliably detect whether the same receipt was already submitted 3 weeks ago or edited.</a:t>
+              <a:t>The human eye cannot spot when the exact same fuel slip was already claimed 3 weeks earlier under a different project code.</a:t>
             </a:r>
           </a:p>
         </p:txBody>
@@ -9013,8 +9058,8 @@
         </p:nvSpPr>
         <p:spPr>
           <a:xfrm>
-            <a:off x="8823960" y="1828800"/>
-            <a:ext cx="2468880" cy="4114800"/>
+            <a:off x="8823960" y="1691640"/>
+            <a:ext cx="2514600" cy="4297680"/>
           </a:xfrm>
           <a:prstGeom prst="roundRect">
             <a:avLst/>
@@ -9062,7 +9107,7 @@
               <a:spcBef>
                 <a:spcPts val="800"/>
               </a:spcBef>
-              <a:defRPr sz="1500" b="1">
+              <a:defRPr sz="1400" b="1">
                 <a:solidFill>
                   <a:srgbClr val="0F172A"/>
                 </a:solidFill>
@@ -9084,7 +9129,7 @@
               </a:defRPr>
             </a:pPr>
             <a:r>
-              <a:t>Ineligible GST claims and missing or invalid 15-digit GSTINs lead to lost Input Tax Credit (ITC) on audits.</a:t>
+              <a:t>Fake, unverified, or non-existent vendor GSTIN numbers invalidate corporate tax deductions, causing lost Input Tax Credit (ITC).</a:t>
             </a:r>
           </a:p>
         </p:txBody>
@@ -9097,7 +9142,7 @@
         </p:nvSpPr>
         <p:spPr>
           <a:xfrm>
-            <a:off x="731520" y="6400800"/>
+            <a:off x="731520" y="6355080"/>
             <a:ext cx="10698480" cy="274320"/>
           </a:xfrm>
           <a:prstGeom prst="rect">
@@ -9120,7 +9165,7 @@
               </a:defRPr>
             </a:pPr>
             <a:r>
-              <a:t>CLAIMGUARD PRODUCT PITCH   |   SLIDE 02 OF 15</a:t>
+              <a:t>CLAIMGUARD PRODUCT PITCH   |   SLIDE 02 OF 15   |   APEX LOGISTICS INDIA PVT LTD</a:t>
             </a:r>
           </a:p>
         </p:txBody>
@@ -9194,8 +9239,8 @@
         </p:nvSpPr>
         <p:spPr>
           <a:xfrm>
-            <a:off x="731520" y="457200"/>
-            <a:ext cx="10698480" cy="365760"/>
+            <a:off x="731520" y="411480"/>
+            <a:ext cx="10698480" cy="320040"/>
           </a:xfrm>
           <a:prstGeom prst="rect">
             <a:avLst/>
@@ -9230,7 +9275,7 @@
         </p:nvSpPr>
         <p:spPr>
           <a:xfrm>
-            <a:off x="731520" y="822960"/>
+            <a:off x="731520" y="731520"/>
             <a:ext cx="10698480" cy="731520"/>
           </a:xfrm>
           <a:prstGeom prst="rect">
@@ -9245,7 +9290,7 @@
           <a:lstStyle/>
           <a:p>
             <a:pPr>
-              <a:defRPr sz="2800" b="1">
+              <a:defRPr sz="2600" b="1">
                 <a:solidFill>
                   <a:srgbClr val="FFFFFF"/>
                 </a:solidFill>
@@ -9266,8 +9311,8 @@
         </p:nvSpPr>
         <p:spPr>
           <a:xfrm>
-            <a:off x="731520" y="1828800"/>
-            <a:ext cx="5120640" cy="4114800"/>
+            <a:off x="731520" y="1691640"/>
+            <a:ext cx="5120640" cy="4297680"/>
           </a:xfrm>
           <a:prstGeom prst="rect">
             <a:avLst/>
@@ -9315,14 +9360,14 @@
               <a:spcBef>
                 <a:spcPts val="1400"/>
               </a:spcBef>
-              <a:defRPr sz="1200">
+              <a:defRPr sz="1150">
                 <a:solidFill>
                   <a:srgbClr val="F8FAFC"/>
                 </a:solidFill>
               </a:defRPr>
             </a:pPr>
             <a:r>
-              <a:t>X  Employee submits crumpled paper / raw photo</a:t>
+              <a:t>X  Employee submits crumpled paper / raw photo without metadata</a:t>
             </a:r>
           </a:p>
           <a:p>
@@ -9330,14 +9375,14 @@
               <a:spcBef>
                 <a:spcPts val="1400"/>
               </a:spcBef>
-              <a:defRPr sz="1200">
+              <a:defRPr sz="1150">
                 <a:solidFill>
                   <a:srgbClr val="F8FAFC"/>
                 </a:solidFill>
               </a:defRPr>
             </a:pPr>
             <a:r>
-              <a:t>X  Piles up in finance inbox for weeks</a:t>
+              <a:t>X  Piles up in finance inbox for weeks in backlog</a:t>
             </a:r>
           </a:p>
           <a:p>
@@ -9345,14 +9390,14 @@
               <a:spcBef>
                 <a:spcPts val="1400"/>
               </a:spcBef>
-              <a:defRPr sz="1200">
+              <a:defRPr sz="1150">
                 <a:solidFill>
                   <a:srgbClr val="F8FAFC"/>
                 </a:solidFill>
               </a:defRPr>
             </a:pPr>
             <a:r>
-              <a:t>X  Manager spends 10 minutes manually verifying math</a:t>
+              <a:t>X  Manager spends 10 minutes manually verifying arithmetic &amp; caps</a:t>
             </a:r>
           </a:p>
           <a:p>
@@ -9360,14 +9405,14 @@
               <a:spcBef>
                 <a:spcPts val="1400"/>
               </a:spcBef>
-              <a:defRPr sz="1200">
+              <a:defRPr sz="1150">
                 <a:solidFill>
                   <a:srgbClr val="F8FAFC"/>
                 </a:solidFill>
               </a:defRPr>
             </a:pPr>
             <a:r>
-              <a:t>X  Duplicate payouts and compliance errors slip through</a:t>
+              <a:t>X  Duplicate payouts and GST compliance errors slip through</a:t>
             </a:r>
           </a:p>
         </p:txBody>
@@ -9380,8 +9425,8 @@
         </p:nvSpPr>
         <p:spPr>
           <a:xfrm>
-            <a:off x="6217920" y="1828800"/>
-            <a:ext cx="5212080" cy="4114800"/>
+            <a:off x="6217920" y="1691640"/>
+            <a:ext cx="5212080" cy="4297680"/>
           </a:xfrm>
           <a:prstGeom prst="rect">
             <a:avLst/>
@@ -9429,14 +9474,14 @@
               <a:spcBef>
                 <a:spcPts val="1000"/>
               </a:spcBef>
-              <a:defRPr sz="1200" b="1">
+              <a:defRPr sz="1150" b="1">
                 <a:solidFill>
                   <a:srgbClr val="FFFFFF"/>
                 </a:solidFill>
               </a:defRPr>
             </a:pPr>
             <a:r>
-              <a:t>-&gt;  Employee captures instant photo via Flutter mobile</a:t>
+              <a:t>-&gt;  Employee captures instant photo via Flutter mobile app</a:t>
             </a:r>
           </a:p>
           <a:p>
@@ -9444,14 +9489,14 @@
               <a:spcBef>
                 <a:spcPts val="1000"/>
               </a:spcBef>
-              <a:defRPr sz="1200" b="1">
+              <a:defRPr sz="1150" b="1">
                 <a:solidFill>
                   <a:srgbClr val="FFFFFF"/>
                 </a:solidFill>
               </a:defRPr>
             </a:pPr>
             <a:r>
-              <a:t>-&gt;  Instant AWS Textract extraction &amp; normalizer</a:t>
+              <a:t>-&gt;  Instant AWS Textract extraction &amp; key-value normalization</a:t>
             </a:r>
           </a:p>
           <a:p>
@@ -9459,14 +9504,14 @@
               <a:spcBef>
                 <a:spcPts val="1000"/>
               </a:spcBef>
-              <a:defRPr sz="1200" b="1">
+              <a:defRPr sz="1150" b="1">
                 <a:solidFill>
                   <a:srgbClr val="FFFFFF"/>
                 </a:solidFill>
               </a:defRPr>
             </a:pPr>
             <a:r>
-              <a:t>-&gt;  Deterministic fraud checks (Hash, GSTIN, Anomaly)</a:t>
+              <a:t>-&gt;  Deterministic fraud checks (Perceptual Hash, GSTIN, Anomaly)</a:t>
             </a:r>
           </a:p>
           <a:p>
@@ -9474,14 +9519,14 @@
               <a:spcBef>
                 <a:spcPts val="1000"/>
               </a:spcBef>
-              <a:defRPr sz="1200" b="1">
+              <a:defRPr sz="1150" b="1">
                 <a:solidFill>
                   <a:srgbClr val="FFFFFF"/>
                 </a:solidFill>
               </a:defRPr>
             </a:pPr>
             <a:r>
-              <a:t>-&gt;  Compounded 0-100 risk score &amp; Bedrock explanation</a:t>
+              <a:t>-&gt;  Compounded 0–100 risk score &amp; Bedrock narrative</a:t>
             </a:r>
           </a:p>
           <a:p>
@@ -9489,14 +9534,14 @@
               <a:spcBef>
                 <a:spcPts val="1000"/>
               </a:spcBef>
-              <a:defRPr sz="1200" b="1">
+              <a:defRPr sz="1150" b="1">
                 <a:solidFill>
                   <a:srgbClr val="FFFFFF"/>
                 </a:solidFill>
               </a:defRPr>
             </a:pPr>
             <a:r>
-              <a:t>-&gt;  Manager receives decision-ready evidence in seconds</a:t>
+              <a:t>-&gt;  Manager reviews decision-ready evidence in seconds</a:t>
             </a:r>
           </a:p>
         </p:txBody>
@@ -9509,7 +9554,7 @@
         </p:nvSpPr>
         <p:spPr>
           <a:xfrm>
-            <a:off x="731520" y="6400800"/>
+            <a:off x="731520" y="6355080"/>
             <a:ext cx="10698480" cy="274320"/>
           </a:xfrm>
           <a:prstGeom prst="rect">
@@ -9532,7 +9577,7 @@
               </a:defRPr>
             </a:pPr>
             <a:r>
-              <a:t>CLAIMGUARD PRODUCT PITCH   |   SLIDE 03 OF 15</a:t>
+              <a:t>CLAIMGUARD PRODUCT PITCH   |   SLIDE 03 OF 15   |   APEX LOGISTICS INDIA PVT LTD</a:t>
             </a:r>
           </a:p>
         </p:txBody>
@@ -9606,8 +9651,8 @@
         </p:nvSpPr>
         <p:spPr>
           <a:xfrm>
-            <a:off x="731520" y="457200"/>
-            <a:ext cx="10698480" cy="365760"/>
+            <a:off x="731520" y="411480"/>
+            <a:ext cx="10698480" cy="320040"/>
           </a:xfrm>
           <a:prstGeom prst="rect">
             <a:avLst/>
@@ -9629,7 +9674,7 @@
               </a:defRPr>
             </a:pPr>
             <a:r>
-              <a:t>END-TO-END ARCHITECTURE</a:t>
+              <a:t>CONTINUOUS PIPELINE</a:t>
             </a:r>
           </a:p>
         </p:txBody>
@@ -9642,7 +9687,7 @@
         </p:nvSpPr>
         <p:spPr>
           <a:xfrm>
-            <a:off x="731520" y="822960"/>
+            <a:off x="731520" y="731520"/>
             <a:ext cx="10698480" cy="731520"/>
           </a:xfrm>
           <a:prstGeom prst="rect">
@@ -9657,7 +9702,7 @@
           <a:lstStyle/>
           <a:p>
             <a:pPr>
-              <a:defRPr sz="2800" b="1">
+              <a:defRPr sz="2600" b="1">
                 <a:solidFill>
                   <a:srgbClr val="0F172A"/>
                 </a:solidFill>
@@ -9678,8 +9723,8 @@
         </p:nvSpPr>
         <p:spPr>
           <a:xfrm>
-            <a:off x="731520" y="1828800"/>
-            <a:ext cx="2514600" cy="1920240"/>
+            <a:off x="731520" y="1691640"/>
+            <a:ext cx="2514600" cy="2011680"/>
           </a:xfrm>
           <a:prstGeom prst="roundRect">
             <a:avLst/>
@@ -9712,14 +9757,29 @@
           <a:lstStyle/>
           <a:p>
             <a:pPr algn="ctr">
+              <a:defRPr sz="900" b="1">
+                <a:solidFill>
+                  <a:srgbClr val="F97316"/>
+                </a:solidFill>
+              </a:defRPr>
+            </a:pPr>
+            <a:r>
+              <a:t>01. CAPTURE</a:t>
+            </a:r>
+          </a:p>
+          <a:p>
+            <a:pPr>
+              <a:spcBef>
+                <a:spcPts val="400"/>
+              </a:spcBef>
               <a:defRPr sz="1300" b="1">
                 <a:solidFill>
-                  <a:srgbClr val="F97316"/>
-                </a:solidFill>
-              </a:defRPr>
-            </a:pPr>
-            <a:r>
-              <a:t>1. CAPTURE</a:t>
+                  <a:srgbClr val="0F172A"/>
+                </a:solidFill>
+              </a:defRPr>
+            </a:pPr>
+            <a:r>
+              <a:t>Mobile Viewfinder</a:t>
             </a:r>
           </a:p>
           <a:p>
@@ -9734,7 +9794,7 @@
               </a:defRPr>
             </a:pPr>
             <a:r>
-              <a:t>Mobile Flutter app captures receipt image with alignment guidance.</a:t>
+              <a:t>Rahul snaps fuel receipt in Flutter app with edge alignment.</a:t>
             </a:r>
           </a:p>
         </p:txBody>
@@ -9747,8 +9807,8 @@
         </p:nvSpPr>
         <p:spPr>
           <a:xfrm>
-            <a:off x="3429000" y="1828800"/>
-            <a:ext cx="2514600" cy="1920240"/>
+            <a:off x="3429000" y="1691640"/>
+            <a:ext cx="2514600" cy="2011680"/>
           </a:xfrm>
           <a:prstGeom prst="roundRect">
             <a:avLst/>
@@ -9781,14 +9841,29 @@
           <a:lstStyle/>
           <a:p>
             <a:pPr algn="ctr">
+              <a:defRPr sz="900" b="1">
+                <a:solidFill>
+                  <a:srgbClr val="F97316"/>
+                </a:solidFill>
+              </a:defRPr>
+            </a:pPr>
+            <a:r>
+              <a:t>02. EXTRACT</a:t>
+            </a:r>
+          </a:p>
+          <a:p>
+            <a:pPr>
+              <a:spcBef>
+                <a:spcPts val="400"/>
+              </a:spcBef>
               <a:defRPr sz="1300" b="1">
                 <a:solidFill>
-                  <a:srgbClr val="F97316"/>
-                </a:solidFill>
-              </a:defRPr>
-            </a:pPr>
-            <a:r>
-              <a:t>2. EXTRACT</a:t>
+                  <a:srgbClr val="0F172A"/>
+                </a:solidFill>
+              </a:defRPr>
+            </a:pPr>
+            <a:r>
+              <a:t>AWS Textract OCR</a:t>
             </a:r>
           </a:p>
           <a:p>
@@ -9803,7 +9878,7 @@
               </a:defRPr>
             </a:pPr>
             <a:r>
-              <a:t>AWS Textract extracts vendor, date, total, GSTIN &amp; line items.</a:t>
+              <a:t>Extracts Indian Oil Corp, ₹1,850.00, Date &amp; 15-char GSTIN.</a:t>
             </a:r>
           </a:p>
         </p:txBody>
@@ -9816,8 +9891,8 @@
         </p:nvSpPr>
         <p:spPr>
           <a:xfrm>
-            <a:off x="6126480" y="1828800"/>
-            <a:ext cx="2514600" cy="1920240"/>
+            <a:off x="6126480" y="1691640"/>
+            <a:ext cx="2514600" cy="2011680"/>
           </a:xfrm>
           <a:prstGeom prst="roundRect">
             <a:avLst/>
@@ -9850,14 +9925,29 @@
           <a:lstStyle/>
           <a:p>
             <a:pPr algn="ctr">
+              <a:defRPr sz="900" b="1">
+                <a:solidFill>
+                  <a:srgbClr val="F97316"/>
+                </a:solidFill>
+              </a:defRPr>
+            </a:pPr>
+            <a:r>
+              <a:t>03. VALIDATE</a:t>
+            </a:r>
+          </a:p>
+          <a:p>
+            <a:pPr>
+              <a:spcBef>
+                <a:spcPts val="400"/>
+              </a:spcBef>
               <a:defRPr sz="1300" b="1">
                 <a:solidFill>
-                  <a:srgbClr val="F97316"/>
-                </a:solidFill>
-              </a:defRPr>
-            </a:pPr>
-            <a:r>
-              <a:t>3. VALIDATE</a:t>
+                  <a:srgbClr val="0F172A"/>
+                </a:solidFill>
+              </a:defRPr>
+            </a:pPr>
+            <a:r>
+              <a:t>Policy &amp; Caps</a:t>
             </a:r>
           </a:p>
           <a:p>
@@ -9872,7 +9962,7 @@
               </a:defRPr>
             </a:pPr>
             <a:r>
-              <a:t>Deterministic validation tests date boundaries and math.</a:t>
+              <a:t>Checks fuel cap &lt;= ₹5,000, date within tour, math consistency.</a:t>
             </a:r>
           </a:p>
         </p:txBody>
@@ -9885,8 +9975,8 @@
         </p:nvSpPr>
         <p:spPr>
           <a:xfrm>
-            <a:off x="8823960" y="1828800"/>
-            <a:ext cx="2514600" cy="1920240"/>
+            <a:off x="8823960" y="1691640"/>
+            <a:ext cx="2514600" cy="2011680"/>
           </a:xfrm>
           <a:prstGeom prst="roundRect">
             <a:avLst/>
@@ -9919,14 +10009,29 @@
           <a:lstStyle/>
           <a:p>
             <a:pPr algn="ctr">
+              <a:defRPr sz="900" b="1">
+                <a:solidFill>
+                  <a:srgbClr val="F97316"/>
+                </a:solidFill>
+              </a:defRPr>
+            </a:pPr>
+            <a:r>
+              <a:t>04. DETECT</a:t>
+            </a:r>
+          </a:p>
+          <a:p>
+            <a:pPr>
+              <a:spcBef>
+                <a:spcPts val="400"/>
+              </a:spcBef>
               <a:defRPr sz="1300" b="1">
                 <a:solidFill>
-                  <a:srgbClr val="F97316"/>
-                </a:solidFill>
-              </a:defRPr>
-            </a:pPr>
-            <a:r>
-              <a:t>4. DETECT</a:t>
+                  <a:srgbClr val="0F172A"/>
+                </a:solidFill>
+              </a:defRPr>
+            </a:pPr>
+            <a:r>
+              <a:t>Fraud Signals</a:t>
             </a:r>
           </a:p>
           <a:p>
@@ -9941,7 +10046,7 @@
               </a:defRPr>
             </a:pPr>
             <a:r>
-              <a:t>Perceptual hashing &amp; anomaly baselines detect fraud signals.</a:t>
+              <a:t>Perceptual hash collision check (Hamming &lt;= 5) &amp; GSTIN check.</a:t>
             </a:r>
           </a:p>
         </p:txBody>
@@ -9954,8 +10059,8 @@
         </p:nvSpPr>
         <p:spPr>
           <a:xfrm>
-            <a:off x="1188720" y="4023360"/>
-            <a:ext cx="2926080" cy="1920240"/>
+            <a:off x="731520" y="3931920"/>
+            <a:ext cx="2514600" cy="2011680"/>
           </a:xfrm>
           <a:prstGeom prst="roundRect">
             <a:avLst/>
@@ -9988,14 +10093,29 @@
           <a:lstStyle/>
           <a:p>
             <a:pPr algn="ctr">
+              <a:defRPr sz="900" b="1">
+                <a:solidFill>
+                  <a:srgbClr val="0F172A"/>
+                </a:solidFill>
+              </a:defRPr>
+            </a:pPr>
+            <a:r>
+              <a:t>05. ASSESS</a:t>
+            </a:r>
+          </a:p>
+          <a:p>
+            <a:pPr>
+              <a:spcBef>
+                <a:spcPts val="400"/>
+              </a:spcBef>
               <a:defRPr sz="1300" b="1">
                 <a:solidFill>
-                  <a:srgbClr val="F97316"/>
-                </a:solidFill>
-              </a:defRPr>
-            </a:pPr>
-            <a:r>
-              <a:t>5. ASSESS</a:t>
+                  <a:srgbClr val="0F172A"/>
+                </a:solidFill>
+              </a:defRPr>
+            </a:pPr>
+            <a:r>
+              <a:t>0-100 Risk Engine</a:t>
             </a:r>
           </a:p>
           <a:p>
@@ -10010,7 +10130,7 @@
               </a:defRPr>
             </a:pPr>
             <a:r>
-              <a:t>Deterministic 0-100 scoring derives verified authenticity state.</a:t>
+              <a:t>Calculates score: CLM-4401 = 8 (LOW), CLM-4471 = 65 (HIGH).</a:t>
             </a:r>
           </a:p>
         </p:txBody>
@@ -10023,8 +10143,8 @@
         </p:nvSpPr>
         <p:spPr>
           <a:xfrm>
-            <a:off x="4572000" y="4023360"/>
-            <a:ext cx="2926080" cy="1920240"/>
+            <a:off x="3429000" y="3931920"/>
+            <a:ext cx="2514600" cy="2011680"/>
           </a:xfrm>
           <a:prstGeom prst="roundRect">
             <a:avLst/>
@@ -10057,14 +10177,29 @@
           <a:lstStyle/>
           <a:p>
             <a:pPr algn="ctr">
+              <a:defRPr sz="900" b="1">
+                <a:solidFill>
+                  <a:srgbClr val="0F172A"/>
+                </a:solidFill>
+              </a:defRPr>
+            </a:pPr>
+            <a:r>
+              <a:t>06. REVIEW</a:t>
+            </a:r>
+          </a:p>
+          <a:p>
+            <a:pPr>
+              <a:spcBef>
+                <a:spcPts val="400"/>
+              </a:spcBef>
               <a:defRPr sz="1300" b="1">
                 <a:solidFill>
-                  <a:srgbClr val="F97316"/>
-                </a:solidFill>
-              </a:defRPr>
-            </a:pPr>
-            <a:r>
-              <a:t>6. REVIEW</a:t>
+                  <a:srgbClr val="0F172A"/>
+                </a:solidFill>
+              </a:defRPr>
+            </a:pPr>
+            <a:r>
+              <a:t>Manager Cockpit</a:t>
             </a:r>
           </a:p>
           <a:p>
@@ -10079,7 +10214,7 @@
               </a:defRPr>
             </a:pPr>
             <a:r>
-              <a:t>Manager reviews evidence side-by-side in operations cockpit.</a:t>
+              <a:t>Priya Sharma reviews side-by-side evidence with AI summary.</a:t>
             </a:r>
           </a:p>
         </p:txBody>
@@ -10092,8 +10227,8 @@
         </p:nvSpPr>
         <p:spPr>
           <a:xfrm>
-            <a:off x="7955279" y="4023360"/>
-            <a:ext cx="2926080" cy="1920240"/>
+            <a:off x="6126480" y="3931920"/>
+            <a:ext cx="2514600" cy="2011680"/>
           </a:xfrm>
           <a:prstGeom prst="roundRect">
             <a:avLst/>
@@ -10126,14 +10261,29 @@
           <a:lstStyle/>
           <a:p>
             <a:pPr algn="ctr">
+              <a:defRPr sz="900" b="1">
+                <a:solidFill>
+                  <a:srgbClr val="0F172A"/>
+                </a:solidFill>
+              </a:defRPr>
+            </a:pPr>
+            <a:r>
+              <a:t>07. AUDIT</a:t>
+            </a:r>
+          </a:p>
+          <a:p>
+            <a:pPr>
+              <a:spcBef>
+                <a:spcPts val="400"/>
+              </a:spcBef>
               <a:defRPr sz="1300" b="1">
                 <a:solidFill>
-                  <a:srgbClr val="F97316"/>
-                </a:solidFill>
-              </a:defRPr>
-            </a:pPr>
-            <a:r>
-              <a:t>7. AUDIT</a:t>
+                  <a:srgbClr val="0F172A"/>
+                </a:solidFill>
+              </a:defRPr>
+            </a:pPr>
+            <a:r>
+              <a:t>Supabase Log</a:t>
             </a:r>
           </a:p>
           <a:p>
@@ -10148,20 +10298,99 @@
               </a:defRPr>
             </a:pPr>
             <a:r>
-              <a:t>Append-only immutable audit trail records actor, action &amp; timestamp.</a:t>
-            </a:r>
-          </a:p>
-        </p:txBody>
-      </p:sp>
-      <p:sp>
-        <p:nvSpPr>
-          <p:cNvPr id="12" name="TextBox 11"/>
+              <a:t>Immutable append-only row: actor, timestamp, and audit notes.</a:t>
+            </a:r>
+          </a:p>
+        </p:txBody>
+      </p:sp>
+      <p:sp>
+        <p:nvSpPr>
+          <p:cNvPr id="12" name="Rectangle 11"/>
+          <p:cNvSpPr/>
+          <p:nvPr/>
+        </p:nvSpPr>
+        <p:spPr>
+          <a:xfrm>
+            <a:off x="8823960" y="3931920"/>
+            <a:ext cx="2514600" cy="2011680"/>
+          </a:xfrm>
+          <a:prstGeom prst="rect">
+            <a:avLst/>
+          </a:prstGeom>
+          <a:solidFill>
+            <a:srgbClr val="0F172A"/>
+          </a:solidFill>
+        </p:spPr>
+        <p:style>
+          <a:lnRef idx="1">
+            <a:schemeClr val="accent1"/>
+          </a:lnRef>
+          <a:fillRef idx="3">
+            <a:schemeClr val="accent1"/>
+          </a:fillRef>
+          <a:effectRef idx="2">
+            <a:schemeClr val="accent1"/>
+          </a:effectRef>
+          <a:fontRef idx="minor">
+            <a:schemeClr val="lt1"/>
+          </a:fontRef>
+        </p:style>
+        <p:txBody>
+          <a:bodyPr rtlCol="0" anchor="ctr" wrap="square" lIns="228600" rIns="228600" tIns="228600"/>
+          <a:lstStyle/>
+          <a:p>
+            <a:pPr algn="ctr">
+              <a:defRPr sz="900" b="1">
+                <a:solidFill>
+                  <a:srgbClr val="FDBA74"/>
+                </a:solidFill>
+              </a:defRPr>
+            </a:pPr>
+            <a:r>
+              <a:t>CONTINUOUS AUDIT</a:t>
+            </a:r>
+          </a:p>
+          <a:p>
+            <a:pPr>
+              <a:spcBef>
+                <a:spcPts val="400"/>
+              </a:spcBef>
+              <a:defRPr sz="1400" b="1">
+                <a:solidFill>
+                  <a:srgbClr val="FFFFFF"/>
+                </a:solidFill>
+              </a:defRPr>
+            </a:pPr>
+            <a:r>
+              <a:t>Zero Data Gaps</a:t>
+            </a:r>
+          </a:p>
+          <a:p>
+            <a:pPr>
+              <a:spcBef>
+                <a:spcPts val="600"/>
+              </a:spcBef>
+              <a:defRPr sz="1050">
+                <a:solidFill>
+                  <a:srgbClr val="F8FAFC"/>
+                </a:solidFill>
+              </a:defRPr>
+            </a:pPr>
+            <a:r>
+              <a:t>From shutter click to permanent audit log in &lt; 4 seconds.</a:t>
+            </a:r>
+          </a:p>
+        </p:txBody>
+      </p:sp>
+      <p:sp>
+        <p:nvSpPr>
+          <p:cNvPr id="13" name="TextBox 12"/>
           <p:cNvSpPr txBox="1"/>
           <p:nvPr/>
         </p:nvSpPr>
         <p:spPr>
           <a:xfrm>
-            <a:off x="731520" y="6400800"/>
+            <a:off x="731520" y="6355080"/>
             <a:ext cx="10698480" cy="274320"/>
           </a:xfrm>
           <a:prstGeom prst="rect">
@@ -10184,7 +10413,7 @@
               </a:defRPr>
             </a:pPr>
             <a:r>
-              <a:t>CLAIMGUARD PRODUCT PITCH   |   SLIDE 04 OF 15</a:t>
+              <a:t>CLAIMGUARD PRODUCT PITCH   |   SLIDE 04 OF 15   |   APEX LOGISTICS INDIA PVT LTD</a:t>
             </a:r>
           </a:p>
         </p:txBody>
@@ -10258,8 +10487,8 @@
         </p:nvSpPr>
         <p:spPr>
           <a:xfrm>
-            <a:off x="731520" y="457200"/>
-            <a:ext cx="10698480" cy="365760"/>
+            <a:off x="731520" y="411480"/>
+            <a:ext cx="10698480" cy="320040"/>
           </a:xfrm>
           <a:prstGeom prst="rect">
             <a:avLst/>
@@ -10281,7 +10510,7 @@
               </a:defRPr>
             </a:pPr>
             <a:r>
-              <a:t>FIELD MOBILITY</a:t>
+              <a:t>FIELD MOBILITY &amp; REAL LIVE SESSION</a:t>
             </a:r>
           </a:p>
         </p:txBody>
@@ -10294,7 +10523,7 @@
         </p:nvSpPr>
         <p:spPr>
           <a:xfrm>
-            <a:off x="731520" y="822960"/>
+            <a:off x="731520" y="731520"/>
             <a:ext cx="10698480" cy="731520"/>
           </a:xfrm>
           <a:prstGeom prst="rect">
@@ -10309,7 +10538,7 @@
           <a:lstStyle/>
           <a:p>
             <a:pPr>
-              <a:defRPr sz="2800" b="1">
+              <a:defRPr sz="2600" b="1">
                 <a:solidFill>
                   <a:srgbClr val="0F172A"/>
                 </a:solidFill>
@@ -10330,8 +10559,8 @@
         </p:nvSpPr>
         <p:spPr>
           <a:xfrm>
-            <a:off x="731520" y="1645920"/>
-            <a:ext cx="5486400" cy="4389120"/>
+            <a:off x="731520" y="1691640"/>
+            <a:ext cx="5669280" cy="4389120"/>
           </a:xfrm>
           <a:prstGeom prst="rect">
             <a:avLst/>
@@ -10345,14 +10574,14 @@
           <a:lstStyle/>
           <a:p>
             <a:pPr>
-              <a:defRPr sz="1300" b="1">
+              <a:defRPr sz="1250" b="1">
                 <a:solidFill>
                   <a:srgbClr val="0F172A"/>
                 </a:solidFill>
               </a:defRPr>
             </a:pPr>
             <a:r>
-              <a:t>Cross-Platform Flutter Native</a:t>
+              <a:t>Active Submitter Session: Rahul Kumar</a:t>
             </a:r>
           </a:p>
           <a:p>
@@ -10360,29 +10589,29 @@
               <a:spcBef>
                 <a:spcPts val="200"/>
               </a:spcBef>
-              <a:defRPr sz="1050">
+              <a:defRPr sz="1000">
                 <a:solidFill>
                   <a:srgbClr val="334155"/>
                 </a:solidFill>
               </a:defRPr>
             </a:pPr>
             <a:r>
-              <a:t>Fast, responsive mobile experience optimized for field reps and technicians on Android &amp; iOS.</a:t>
+              <a:t>Senior Field Sales Executive &amp;bull; South Sales &amp;bull; Historical Avg: ₹1,650.00 (38 claims).</a:t>
             </a:r>
           </a:p>
           <a:p>
             <a:pPr>
               <a:spcBef>
-                <a:spcPts val="1000"/>
+                <a:spcPts val="900"/>
               </a:spcBef>
-              <a:defRPr sz="1300" b="1">
+              <a:defRPr sz="1250" b="1">
                 <a:solidFill>
                   <a:srgbClr val="0F172A"/>
                 </a:solidFill>
               </a:defRPr>
             </a:pPr>
             <a:r>
-              <a:t>One-Tap Camera Capture</a:t>
+              <a:t>Live Ingestion: CLM-4401 (Indian Oil Corp)</a:t>
             </a:r>
           </a:p>
           <a:p>
@@ -10390,29 +10619,29 @@
               <a:spcBef>
                 <a:spcPts val="200"/>
               </a:spcBef>
-              <a:defRPr sz="1050">
+              <a:defRPr sz="1000">
                 <a:solidFill>
                   <a:srgbClr val="334155"/>
                 </a:solidFill>
               </a:defRPr>
             </a:pPr>
             <a:r>
-              <a:t>Receipt scanner viewfinder with real-time framing and image stabilization.</a:t>
+              <a:t>Category: Fuel &amp;bull; Amount: ₹1,850.00 &amp;bull; Date: 16 Sep 2026 &amp;bull; Tour: BLR-MYS Regional.</a:t>
             </a:r>
           </a:p>
           <a:p>
             <a:pPr>
               <a:spcBef>
-                <a:spcPts val="1000"/>
+                <a:spcPts val="900"/>
               </a:spcBef>
-              <a:defRPr sz="1300" b="1">
+              <a:defRPr sz="1250" b="1">
                 <a:solidFill>
                   <a:srgbClr val="0F172A"/>
                 </a:solidFill>
               </a:defRPr>
             </a:pPr>
             <a:r>
-              <a:t>Inline Extraction Review</a:t>
+              <a:t>Instant Viewfinder Extraction</a:t>
             </a:r>
           </a:p>
           <a:p>
@@ -10420,22 +10649,22 @@
               <a:spcBef>
                 <a:spcPts val="200"/>
               </a:spcBef>
-              <a:defRPr sz="1050">
+              <a:defRPr sz="1000">
                 <a:solidFill>
                   <a:srgbClr val="334155"/>
                 </a:solidFill>
               </a:defRPr>
             </a:pPr>
             <a:r>
-              <a:t>Instant preview card displaying extracted vendor, date, amount, and category for rapid verification.</a:t>
+              <a:t>Real-time edge framing. The employee snaps the photo and receives structured results in 2 seconds.</a:t>
             </a:r>
           </a:p>
           <a:p>
             <a:pPr>
               <a:spcBef>
-                <a:spcPts val="1000"/>
+                <a:spcPts val="900"/>
               </a:spcBef>
-              <a:defRPr sz="1300" b="1">
+              <a:defRPr sz="1250" b="1">
                 <a:solidFill>
                   <a:srgbClr val="0F172A"/>
                 </a:solidFill>
@@ -10450,7 +10679,7 @@
               <a:spcBef>
                 <a:spcPts val="200"/>
               </a:spcBef>
-              <a:defRPr sz="1050">
+              <a:defRPr sz="1000">
                 <a:solidFill>
                   <a:srgbClr val="334155"/>
                 </a:solidFill>
@@ -10463,16 +10692,16 @@
           <a:p>
             <a:pPr>
               <a:spcBef>
-                <a:spcPts val="1000"/>
+                <a:spcPts val="900"/>
               </a:spcBef>
-              <a:defRPr sz="1300" b="1">
+              <a:defRPr sz="1250" b="1">
                 <a:solidFill>
                   <a:srgbClr val="0F172A"/>
                 </a:solidFill>
               </a:defRPr>
             </a:pPr>
             <a:r>
-              <a:t>Live Status Tracking</a:t>
+              <a:t>Instant Push Status Sync</a:t>
             </a:r>
           </a:p>
           <a:p>
@@ -10480,14 +10709,14 @@
               <a:spcBef>
                 <a:spcPts val="200"/>
               </a:spcBef>
-              <a:defRPr sz="1050">
+              <a:defRPr sz="1000">
                 <a:solidFill>
                   <a:srgbClr val="334155"/>
                 </a:solidFill>
               </a:defRPr>
             </a:pPr>
             <a:r>
-              <a:t>Instant push cards notify field staff the moment a claim is verified, reviewed, or approved.</a:t>
+              <a:t>Push cards notify field staff the moment a claim is verified, reviewed, or approved.</a:t>
             </a:r>
           </a:p>
         </p:txBody>
@@ -10508,8 +10737,8 @@
         </p:blipFill>
         <p:spPr>
           <a:xfrm>
-            <a:off x="6583680" y="1645920"/>
-            <a:ext cx="4846320" cy="2704923"/>
+            <a:off x="6675120" y="1691640"/>
+            <a:ext cx="4754880" cy="2653887"/>
           </a:xfrm>
           <a:prstGeom prst="rect">
             <a:avLst/>
@@ -10524,7 +10753,7 @@
         </p:nvSpPr>
         <p:spPr>
           <a:xfrm>
-            <a:off x="731520" y="6400800"/>
+            <a:off x="731520" y="6355080"/>
             <a:ext cx="10698480" cy="274320"/>
           </a:xfrm>
           <a:prstGeom prst="rect">
@@ -10547,7 +10776,7 @@
               </a:defRPr>
             </a:pPr>
             <a:r>
-              <a:t>CLAIMGUARD PRODUCT PITCH   |   SLIDE 05 OF 15</a:t>
+              <a:t>CLAIMGUARD PRODUCT PITCH   |   SLIDE 05 OF 15   |   APEX LOGISTICS INDIA PVT LTD</a:t>
             </a:r>
           </a:p>
         </p:txBody>
@@ -10621,8 +10850,8 @@
         </p:nvSpPr>
         <p:spPr>
           <a:xfrm>
-            <a:off x="731520" y="457200"/>
-            <a:ext cx="10698480" cy="365760"/>
+            <a:off x="731520" y="411480"/>
+            <a:ext cx="10698480" cy="320040"/>
           </a:xfrm>
           <a:prstGeom prst="rect">
             <a:avLst/>
@@ -10644,7 +10873,7 @@
               </a:defRPr>
             </a:pPr>
             <a:r>
-              <a:t>OPERATIONS COCKPIT</a:t>
+              <a:t>OPERATIONS COCKPIT &amp; LIVE REVIEW</a:t>
             </a:r>
           </a:p>
         </p:txBody>
@@ -10657,7 +10886,7 @@
         </p:nvSpPr>
         <p:spPr>
           <a:xfrm>
-            <a:off x="731520" y="822960"/>
+            <a:off x="731520" y="731520"/>
             <a:ext cx="10698480" cy="731520"/>
           </a:xfrm>
           <a:prstGeom prst="rect">
@@ -10672,7 +10901,7 @@
           <a:lstStyle/>
           <a:p>
             <a:pPr>
-              <a:defRPr sz="2800" b="1">
+              <a:defRPr sz="2600" b="1">
                 <a:solidFill>
                   <a:srgbClr val="0F172A"/>
                 </a:solidFill>
@@ -10701,8 +10930,8 @@
         </p:blipFill>
         <p:spPr>
           <a:xfrm>
-            <a:off x="731520" y="1645920"/>
-            <a:ext cx="5486400" cy="3062177"/>
+            <a:off x="731520" y="1691640"/>
+            <a:ext cx="5120640" cy="2858032"/>
           </a:xfrm>
           <a:prstGeom prst="rect">
             <a:avLst/>
@@ -10717,8 +10946,8 @@
         </p:nvSpPr>
         <p:spPr>
           <a:xfrm>
-            <a:off x="6492240" y="1645920"/>
-            <a:ext cx="4937760" cy="4389120"/>
+            <a:off x="6126480" y="1691640"/>
+            <a:ext cx="5303520" cy="4389120"/>
           </a:xfrm>
           <a:prstGeom prst="rect">
             <a:avLst/>
@@ -10732,14 +10961,14 @@
           <a:lstStyle/>
           <a:p>
             <a:pPr>
-              <a:defRPr sz="1300" b="1">
+              <a:defRPr sz="1250" b="1">
                 <a:solidFill>
                   <a:srgbClr val="0F172A"/>
                 </a:solidFill>
               </a:defRPr>
             </a:pPr>
             <a:r>
-              <a:t>Split-Screen Verification View</a:t>
+              <a:t>Active Controller: Priya Sharma</a:t>
             </a:r>
           </a:p>
           <a:p>
@@ -10747,29 +10976,29 @@
               <a:spcBef>
                 <a:spcPts val="200"/>
               </a:spcBef>
-              <a:defRPr sz="1050">
+              <a:defRPr sz="1000">
                 <a:solidFill>
                   <a:srgbClr val="334155"/>
                 </a:solidFill>
               </a:defRPr>
             </a:pPr>
             <a:r>
-              <a:t>Original high-res receipt on the left; structured extracted values and tax identifiers on the right.</a:t>
+              <a:t>Finance Operations Controller &amp;bull; Reviewing CLM-4471 (Flagged Duplicate Suspect).</a:t>
             </a:r>
           </a:p>
           <a:p>
             <a:pPr>
               <a:spcBef>
-                <a:spcPts val="1000"/>
+                <a:spcPts val="900"/>
               </a:spcBef>
-              <a:defRPr sz="1300" b="1">
+              <a:defRPr sz="1250" b="1">
                 <a:solidFill>
                   <a:srgbClr val="0F172A"/>
                 </a:solidFill>
               </a:defRPr>
             </a:pPr>
             <a:r>
-              <a:t>Prioritized Risk Triage</a:t>
+              <a:t>Flagged Evidence: Indian Oil Corp (₹3,850)</a:t>
             </a:r>
           </a:p>
           <a:p>
@@ -10777,29 +11006,33 @@
               <a:spcBef>
                 <a:spcPts val="200"/>
               </a:spcBef>
-              <a:defRPr sz="1050">
+              <a:defRPr sz="1000">
                 <a:solidFill>
                   <a:srgbClr val="334155"/>
                 </a:solidFill>
               </a:defRPr>
             </a:pPr>
             <a:r>
-              <a:t>Queue dynamically filtered by risk: Low (batch approve), Medium, High, or Critical.</a:t>
+              <a:t>Duplicate Hash: Matches prior claim CLM-3902 (Hamming &lt;= 5).</a:t>
+            </a:r>
+            <a:br/>
+            <a:r>
+              <a:t>Anomaly Spike: ₹3,850 is 2.33x employee category baseline (₹1,650).</a:t>
             </a:r>
           </a:p>
           <a:p>
             <a:pPr>
               <a:spcBef>
-                <a:spcPts val="1000"/>
+                <a:spcPts val="900"/>
               </a:spcBef>
-              <a:defRPr sz="1300" b="1">
+              <a:defRPr sz="1250" b="1">
                 <a:solidFill>
                   <a:srgbClr val="0F172A"/>
                 </a:solidFill>
               </a:defRPr>
             </a:pPr>
             <a:r>
-              <a:t>Evidence-Backed Indicators</a:t>
+              <a:t>Split-Screen Verification Cockpit</a:t>
             </a:r>
           </a:p>
           <a:p>
@@ -10807,29 +11040,29 @@
               <a:spcBef>
                 <a:spcPts val="200"/>
               </a:spcBef>
-              <a:defRPr sz="1050">
+              <a:defRPr sz="1000">
                 <a:solidFill>
                   <a:srgbClr val="334155"/>
                 </a:solidFill>
               </a:defRPr>
             </a:pPr>
             <a:r>
-              <a:t>Hoverable duplicate hash comparisons, historical spending baselines, and GSTIN check logs.</a:t>
+              <a:t>Original high-res receipt on the left; normalized key-values and GSTIN validation on the right.</a:t>
             </a:r>
           </a:p>
           <a:p>
             <a:pPr>
               <a:spcBef>
-                <a:spcPts val="1000"/>
+                <a:spcPts val="900"/>
               </a:spcBef>
-              <a:defRPr sz="1300" b="1">
+              <a:defRPr sz="1250" b="1">
                 <a:solidFill>
                   <a:srgbClr val="0F172A"/>
                 </a:solidFill>
               </a:defRPr>
             </a:pPr>
             <a:r>
-              <a:t>Explainable AI Summaries</a:t>
+              <a:t>Prioritized Risk Triage</a:t>
             </a:r>
           </a:p>
           <a:p>
@@ -10837,22 +11070,22 @@
               <a:spcBef>
                 <a:spcPts val="200"/>
               </a:spcBef>
-              <a:defRPr sz="1050">
+              <a:defRPr sz="1000">
                 <a:solidFill>
                   <a:srgbClr val="334155"/>
                 </a:solidFill>
               </a:defRPr>
             </a:pPr>
             <a:r>
-              <a:t>Claude 3.5 synthesis on AWS Bedrock summarizes key flags into two actionable sentences.</a:t>
+              <a:t>Queue dynamically filtered: Low (batch approve), Medium, High, or Critical.</a:t>
             </a:r>
           </a:p>
           <a:p>
             <a:pPr>
               <a:spcBef>
-                <a:spcPts val="1000"/>
+                <a:spcPts val="900"/>
               </a:spcBef>
-              <a:defRPr sz="1300" b="1">
+              <a:defRPr sz="1250" b="1">
                 <a:solidFill>
                   <a:srgbClr val="0F172A"/>
                 </a:solidFill>
@@ -10867,14 +11100,14 @@
               <a:spcBef>
                 <a:spcPts val="200"/>
               </a:spcBef>
-              <a:defRPr sz="1050">
+              <a:defRPr sz="1000">
                 <a:solidFill>
                   <a:srgbClr val="334155"/>
                 </a:solidFill>
               </a:defRPr>
             </a:pPr>
             <a:r>
-              <a:t>Approve, Reject, or Request Clarification with mandatory compliance notes recorded in Supabase.</a:t>
+              <a:t>Approve, Reject, or Request Clarification with mandatory compliance notes committed to Supabase.</a:t>
             </a:r>
           </a:p>
         </p:txBody>
@@ -10887,7 +11120,7 @@
         </p:nvSpPr>
         <p:spPr>
           <a:xfrm>
-            <a:off x="731520" y="6400800"/>
+            <a:off x="731520" y="6355080"/>
             <a:ext cx="10698480" cy="274320"/>
           </a:xfrm>
           <a:prstGeom prst="rect">
@@ -10910,7 +11143,7 @@
               </a:defRPr>
             </a:pPr>
             <a:r>
-              <a:t>CLAIMGUARD PRODUCT PITCH   |   SLIDE 06 OF 15</a:t>
+              <a:t>CLAIMGUARD PRODUCT PITCH   |   SLIDE 06 OF 15   |   APEX LOGISTICS INDIA PVT LTD</a:t>
             </a:r>
           </a:p>
         </p:txBody>
@@ -10984,8 +11217,8 @@
         </p:nvSpPr>
         <p:spPr>
           <a:xfrm>
-            <a:off x="731520" y="457200"/>
-            <a:ext cx="10698480" cy="365760"/>
+            <a:off x="731520" y="411480"/>
+            <a:ext cx="10698480" cy="320040"/>
           </a:xfrm>
           <a:prstGeom prst="rect">
             <a:avLst/>
@@ -11007,7 +11240,7 @@
               </a:defRPr>
             </a:pPr>
             <a:r>
-              <a:t>DOCUMENT INTELLIGENCE</a:t>
+              <a:t>DOCUMENT INTELLIGENCE &amp; REAL PAYLOAD</a:t>
             </a:r>
           </a:p>
         </p:txBody>
@@ -11020,7 +11253,7 @@
         </p:nvSpPr>
         <p:spPr>
           <a:xfrm>
-            <a:off x="731520" y="822960"/>
+            <a:off x="731520" y="731520"/>
             <a:ext cx="10698480" cy="731520"/>
           </a:xfrm>
           <a:prstGeom prst="rect">
@@ -11035,7 +11268,7 @@
           <a:lstStyle/>
           <a:p>
             <a:pPr>
-              <a:defRPr sz="2800" b="1">
+              <a:defRPr sz="2600" b="1">
                 <a:solidFill>
                   <a:srgbClr val="FFFFFF"/>
                 </a:solidFill>
@@ -11064,8 +11297,8 @@
         </p:blipFill>
         <p:spPr>
           <a:xfrm>
-            <a:off x="731520" y="1645920"/>
-            <a:ext cx="5486400" cy="3062177"/>
+            <a:off x="731520" y="1691640"/>
+            <a:ext cx="5029200" cy="2806995"/>
           </a:xfrm>
           <a:prstGeom prst="rect">
             <a:avLst/>
@@ -11080,8 +11313,8 @@
         </p:nvSpPr>
         <p:spPr>
           <a:xfrm>
-            <a:off x="6492240" y="1645920"/>
-            <a:ext cx="4937760" cy="4389120"/>
+            <a:off x="6035040" y="1691640"/>
+            <a:ext cx="5394960" cy="4297680"/>
           </a:xfrm>
           <a:prstGeom prst="rect">
             <a:avLst/>
@@ -11114,14 +11347,14 @@
           <a:lstStyle/>
           <a:p>
             <a:pPr algn="ctr">
-              <a:defRPr sz="1300" b="1">
+              <a:defRPr sz="1100" b="1">
                 <a:solidFill>
                   <a:srgbClr val="FDBA74"/>
                 </a:solidFill>
               </a:defRPr>
             </a:pPr>
             <a:r>
-              <a:t>WHAT OCR DOES</a:t>
+              <a:t>VERIFIED TEXTRACT EXTRACTION: CLM-4401</a:t>
             </a:r>
           </a:p>
           <a:p>
@@ -11129,29 +11362,14 @@
               <a:spcBef>
                 <a:spcPts val="600"/>
               </a:spcBef>
-              <a:defRPr sz="1100">
-                <a:solidFill>
-                  <a:srgbClr val="F8FAFC"/>
-                </a:solidFill>
-              </a:defRPr>
-            </a:pPr>
-            <a:r>
-              <a:t>AWS Textract AnalyzeExpense parses geometric bounding boxes, summary key-values, and line items. Extracts Merchant Name, Total Amount, Date, and 15-character Indian GSTIN with individual confidence scores.</a:t>
-            </a:r>
-          </a:p>
-          <a:p>
-            <a:pPr>
-              <a:spcBef>
-                <a:spcPts val="1600"/>
-              </a:spcBef>
-              <a:defRPr sz="1300" b="1">
-                <a:solidFill>
-                  <a:srgbClr val="F97316"/>
-                </a:solidFill>
-              </a:defRPr>
-            </a:pPr>
-            <a:r>
-              <a:t>THE FUNDAMENTAL PRINCIPLE</a:t>
+              <a:defRPr sz="1000">
+                <a:solidFill>
+                  <a:srgbClr val="FFFFFF"/>
+                </a:solidFill>
+              </a:defRPr>
+            </a:pPr>
+            <a:r>
+              <a:t>VENDOR:  'Indian Oil Corporation Ltd' (98% Confidence)</a:t>
             </a:r>
           </a:p>
           <a:p>
@@ -11159,23 +11377,98 @@
               <a:spcBef>
                 <a:spcPts val="600"/>
               </a:spcBef>
-              <a:defRPr sz="1100">
+              <a:defRPr sz="1000">
                 <a:solidFill>
                   <a:srgbClr val="FFFFFF"/>
                 </a:solidFill>
               </a:defRPr>
             </a:pPr>
             <a:r>
-              <a:t>OCR asks: 'What does this receipt say?'</a:t>
+              <a:t>AMOUNT:  1850.00 INR (99% Confidence)</a:t>
+            </a:r>
+          </a:p>
+          <a:p>
+            <a:pPr>
+              <a:spcBef>
+                <a:spcPts val="600"/>
+              </a:spcBef>
+              <a:defRPr sz="1000">
+                <a:solidFill>
+                  <a:srgbClr val="FFFFFF"/>
+                </a:solidFill>
+              </a:defRPr>
+            </a:pPr>
+            <a:r>
+              <a:t>DATE:    '2026-09-16' (Normalized from '16/09/2026')</a:t>
+            </a:r>
+          </a:p>
+          <a:p>
+            <a:pPr>
+              <a:spcBef>
+                <a:spcPts val="600"/>
+              </a:spcBef>
+              <a:defRPr sz="1000">
+                <a:solidFill>
+                  <a:srgbClr val="FFFFFF"/>
+                </a:solidFill>
+              </a:defRPr>
+            </a:pPr>
+            <a:r>
+              <a:t>GSTIN:   '29AAACI1681G1ZS' (92% Confidence &amp;bull; Karnataka)</a:t>
+            </a:r>
+          </a:p>
+          <a:p>
+            <a:pPr>
+              <a:spcBef>
+                <a:spcPts val="600"/>
+              </a:spcBef>
+              <a:defRPr sz="1000">
+                <a:solidFill>
+                  <a:srgbClr val="FFFFFF"/>
+                </a:solidFill>
+              </a:defRPr>
+            </a:pPr>
+            <a:r>
+              <a:t>ITEMS:   [{'item': 'Diesel High Speed', 'amount': 1850.00}]</a:t>
+            </a:r>
+          </a:p>
+          <a:p>
+            <a:pPr>
+              <a:spcBef>
+                <a:spcPts val="1400"/>
+              </a:spcBef>
+              <a:defRPr sz="1100" b="1">
+                <a:solidFill>
+                  <a:srgbClr val="F97316"/>
+                </a:solidFill>
+              </a:defRPr>
+            </a:pPr>
+            <a:r>
+              <a:t>THE FUNDAMENTAL PRINCIPLE</a:t>
+            </a:r>
+          </a:p>
+          <a:p>
+            <a:pPr>
+              <a:spcBef>
+                <a:spcPts val="400"/>
+              </a:spcBef>
+              <a:defRPr sz="1050">
+                <a:solidFill>
+                  <a:srgbClr val="F8FAFC"/>
+                </a:solidFill>
+              </a:defRPr>
+            </a:pPr>
+            <a:r>
+              <a:t>OCR asks: 'What text does this document contain?'</a:t>
             </a:r>
             <a:br/>
             <a:r>
-              <a:t>OCR does NOT ask: 'Is this receipt authentic?'</a:t>
+              <a:t>OCR does NOT ask: 'Is this document legitimate?'</a:t>
             </a:r>
             <a:br/>
             <a:br/>
             <a:r>
-              <a:t>A completely fake, fabricated invoice printed on paper will extract with 100% OCR confidence. That is why OCR is only step one.</a:t>
+              <a:t>A completely fake receipt printed on paper will extract with 100% confidence. That is why OCR is only the starting point.</a:t>
             </a:r>
           </a:p>
         </p:txBody>
@@ -11188,7 +11481,7 @@
         </p:nvSpPr>
         <p:spPr>
           <a:xfrm>
-            <a:off x="731520" y="6400800"/>
+            <a:off x="731520" y="6355080"/>
             <a:ext cx="10698480" cy="274320"/>
           </a:xfrm>
           <a:prstGeom prst="rect">
@@ -11211,7 +11504,7 @@
               </a:defRPr>
             </a:pPr>
             <a:r>
-              <a:t>CLAIMGUARD PRODUCT PITCH   |   SLIDE 07 OF 15</a:t>
+              <a:t>CLAIMGUARD PRODUCT PITCH   |   SLIDE 07 OF 15   |   APEX LOGISTICS INDIA PVT LTD</a:t>
             </a:r>
           </a:p>
         </p:txBody>
@@ -11285,8 +11578,8 @@
         </p:nvSpPr>
         <p:spPr>
           <a:xfrm>
-            <a:off x="731520" y="457200"/>
-            <a:ext cx="10698480" cy="365760"/>
+            <a:off x="731520" y="411480"/>
+            <a:ext cx="10698480" cy="320040"/>
           </a:xfrm>
           <a:prstGeom prst="rect">
             <a:avLst/>
@@ -11321,7 +11614,7 @@
         </p:nvSpPr>
         <p:spPr>
           <a:xfrm>
-            <a:off x="731520" y="822960"/>
+            <a:off x="731520" y="731520"/>
             <a:ext cx="10698480" cy="731520"/>
           </a:xfrm>
           <a:prstGeom prst="rect">
@@ -11336,7 +11629,7 @@
           <a:lstStyle/>
           <a:p>
             <a:pPr>
-              <a:defRPr sz="2800" b="1">
+              <a:defRPr sz="2600" b="1">
                 <a:solidFill>
                   <a:srgbClr val="0F172A"/>
                 </a:solidFill>
@@ -11357,7 +11650,7 @@
         </p:nvSpPr>
         <p:spPr>
           <a:xfrm>
-            <a:off x="731520" y="1737360"/>
+            <a:off x="731520" y="1691640"/>
             <a:ext cx="3383280" cy="2011680"/>
           </a:xfrm>
           <a:prstGeom prst="roundRect">
@@ -11406,7 +11699,7 @@
               <a:spcBef>
                 <a:spcPts val="400"/>
               </a:spcBef>
-              <a:defRPr sz="1300" b="1">
+              <a:defRPr sz="1200" b="1">
                 <a:solidFill>
                   <a:srgbClr val="0F172A"/>
                 </a:solidFill>
@@ -11421,14 +11714,14 @@
               <a:spcBef>
                 <a:spcPts val="600"/>
               </a:spcBef>
-              <a:defRPr sz="1000">
+              <a:defRPr sz="950">
                 <a:solidFill>
                   <a:srgbClr val="334155"/>
                 </a:solidFill>
               </a:defRPr>
             </a:pPr>
             <a:r>
-              <a:t>Hamming distance &lt;= 5 flags exact or cropped duplicate receipts.</a:t>
+              <a:t>Visual hash matches prior claim CLM-3902 (Hamming &lt;= 5).</a:t>
             </a:r>
           </a:p>
         </p:txBody>
@@ -11441,7 +11734,7 @@
         </p:nvSpPr>
         <p:spPr>
           <a:xfrm>
-            <a:off x="4389120" y="1737360"/>
+            <a:off x="4389120" y="1691640"/>
             <a:ext cx="3383280" cy="2011680"/>
           </a:xfrm>
           <a:prstGeom prst="roundRect">
@@ -11477,12 +11770,12 @@
             <a:pPr algn="ctr">
               <a:defRPr sz="1000" b="1">
                 <a:solidFill>
-                  <a:srgbClr val="D97706"/>
-                </a:solidFill>
-              </a:defRPr>
-            </a:pPr>
-            <a:r>
-              <a:t>+25 PTS</a:t>
+                  <a:srgbClr val="16A34A"/>
+                </a:solidFill>
+              </a:defRPr>
+            </a:pPr>
+            <a:r>
+              <a:t>0 PTS &amp;bull; PASS</a:t>
             </a:r>
           </a:p>
           <a:p>
@@ -11490,14 +11783,14 @@
               <a:spcBef>
                 <a:spcPts val="400"/>
               </a:spcBef>
-              <a:defRPr sz="1300" b="1">
+              <a:defRPr sz="1200" b="1">
                 <a:solidFill>
                   <a:srgbClr val="0F172A"/>
                 </a:solidFill>
               </a:defRPr>
             </a:pPr>
             <a:r>
-              <a:t>Indian GSTIN Checksum</a:t>
+              <a:t>GSTIN Luhn Checksum</a:t>
             </a:r>
           </a:p>
           <a:p>
@@ -11505,14 +11798,14 @@
               <a:spcBef>
                 <a:spcPts val="600"/>
               </a:spcBef>
-              <a:defRPr sz="1000">
+              <a:defRPr sz="950">
                 <a:solidFill>
                   <a:srgbClr val="334155"/>
                 </a:solidFill>
               </a:defRPr>
             </a:pPr>
             <a:r>
-              <a:t>Validates 15-char tax ID against state codes &amp; ISO 7064 Modulo 36.</a:t>
+              <a:t>Tax ID 29AAACI1681G1ZS passes Karnataka state code 29 &amp; Modulo 36.</a:t>
             </a:r>
           </a:p>
         </p:txBody>
@@ -11525,7 +11818,7 @@
         </p:nvSpPr>
         <p:spPr>
           <a:xfrm>
-            <a:off x="8046720" y="1737360"/>
+            <a:off x="8046720" y="1691640"/>
             <a:ext cx="3383280" cy="2011680"/>
           </a:xfrm>
           <a:prstGeom prst="roundRect">
@@ -11574,14 +11867,14 @@
               <a:spcBef>
                 <a:spcPts val="400"/>
               </a:spcBef>
-              <a:defRPr sz="1300" b="1">
+              <a:defRPr sz="1200" b="1">
                 <a:solidFill>
                   <a:srgbClr val="0F172A"/>
                 </a:solidFill>
               </a:defRPr>
             </a:pPr>
             <a:r>
-              <a:t>Historical Amount Anomaly</a:t>
+              <a:t>Amount Anomaly Baseline</a:t>
             </a:r>
           </a:p>
           <a:p>
@@ -11589,14 +11882,14 @@
               <a:spcBef>
                 <a:spcPts val="600"/>
               </a:spcBef>
-              <a:defRPr sz="1000">
+              <a:defRPr sz="950">
                 <a:solidFill>
                   <a:srgbClr val="334155"/>
                 </a:solidFill>
               </a:defRPr>
             </a:pPr>
             <a:r>
-              <a:t>Flags expenses exceeding 2.0x employee's historical category average.</a:t>
+              <a:t>Amount ₹3,850.00 is 2.33x Rahul Kumar's historical category avg (₹1,650).</a:t>
             </a:r>
           </a:p>
         </p:txBody>
@@ -11645,12 +11938,12 @@
             <a:pPr algn="ctr">
               <a:defRPr sz="1000" b="1">
                 <a:solidFill>
-                  <a:srgbClr val="D97706"/>
-                </a:solidFill>
-              </a:defRPr>
-            </a:pPr>
-            <a:r>
-              <a:t>+20 PTS</a:t>
+                  <a:srgbClr val="16A34A"/>
+                </a:solidFill>
+              </a:defRPr>
+            </a:pPr>
+            <a:r>
+              <a:t>0 PTS &amp;bull; PASS</a:t>
             </a:r>
           </a:p>
           <a:p>
@@ -11658,14 +11951,14 @@
               <a:spcBef>
                 <a:spcPts val="400"/>
               </a:spcBef>
-              <a:defRPr sz="1300" b="1">
+              <a:defRPr sz="1200" b="1">
                 <a:solidFill>
                   <a:srgbClr val="0F172A"/>
                 </a:solidFill>
               </a:defRPr>
             </a:pPr>
             <a:r>
-              <a:t>Category Keyword Mismatch</a:t>
+              <a:t>Merchant Category Match</a:t>
             </a:r>
           </a:p>
           <a:p>
@@ -11673,14 +11966,14 @@
               <a:spcBef>
                 <a:spcPts val="600"/>
               </a:spcBef>
-              <a:defRPr sz="1000">
+              <a:defRPr sz="950">
                 <a:solidFill>
                   <a:srgbClr val="334155"/>
                 </a:solidFill>
               </a:defRPr>
             </a:pPr>
             <a:r>
-              <a:t>Detects dining, alcohol or personal purchases tagged as Fuel/Travel.</a:t>
+              <a:t>Indian Oil line items (Diesel) match policy category FUEL.</a:t>
             </a:r>
           </a:p>
         </p:txBody>
@@ -11734,7 +12027,7 @@
               </a:defRPr>
             </a:pPr>
             <a:r>
-              <a:t>+15 PTS</a:t>
+              <a:t>+5 PTS</a:t>
             </a:r>
           </a:p>
           <a:p>
@@ -11742,14 +12035,14 @@
               <a:spcBef>
                 <a:spcPts val="400"/>
               </a:spcBef>
-              <a:defRPr sz="1300" b="1">
+              <a:defRPr sz="1200" b="1">
                 <a:solidFill>
                   <a:srgbClr val="0F172A"/>
                 </a:solidFill>
               </a:defRPr>
             </a:pPr>
             <a:r>
-              <a:t>Policy Cap Violation</a:t>
+              <a:t>Policy Cap Evaluation</a:t>
             </a:r>
           </a:p>
           <a:p>
@@ -11757,14 +12050,14 @@
               <a:spcBef>
                 <a:spcPts val="600"/>
               </a:spcBef>
-              <a:defRPr sz="1000">
+              <a:defRPr sz="950">
                 <a:solidFill>
                   <a:srgbClr val="334155"/>
                 </a:solidFill>
               </a:defRPr>
             </a:pPr>
             <a:r>
-              <a:t>Enforces single-claim expenditure limits and tax invoice thresholds.</a:t>
+              <a:t>Under single max limit (₹5,000) but triggers daily travel cap review.</a:t>
             </a:r>
           </a:p>
         </p:txBody>
@@ -11813,12 +12106,12 @@
             <a:pPr algn="ctr">
               <a:defRPr sz="1000" b="1">
                 <a:solidFill>
-                  <a:srgbClr val="334155"/>
-                </a:solidFill>
-              </a:defRPr>
-            </a:pPr>
-            <a:r>
-              <a:t>+15 PTS</a:t>
+                  <a:srgbClr val="16A34A"/>
+                </a:solidFill>
+              </a:defRPr>
+            </a:pPr>
+            <a:r>
+              <a:t>0 PTS &amp;bull; PASS</a:t>
             </a:r>
           </a:p>
           <a:p>
@@ -11826,14 +12119,14 @@
               <a:spcBef>
                 <a:spcPts val="400"/>
               </a:spcBef>
-              <a:defRPr sz="1300" b="1">
+              <a:defRPr sz="1200" b="1">
                 <a:solidFill>
                   <a:srgbClr val="0F172A"/>
                 </a:solidFill>
               </a:defRPr>
             </a:pPr>
             <a:r>
-              <a:t>Date &amp; Timing Anomaly</a:t>
+              <a:t>Date &amp; Tour Consistency</a:t>
             </a:r>
           </a:p>
           <a:p>
@@ -11841,14 +12134,14 @@
               <a:spcBef>
                 <a:spcPts val="600"/>
               </a:spcBef>
-              <a:defRPr sz="1000">
+              <a:defRPr sz="950">
                 <a:solidFill>
                   <a:srgbClr val="334155"/>
                 </a:solidFill>
               </a:defRPr>
             </a:pPr>
             <a:r>
-              <a:t>Flags backdated claims &gt;90 days old or impossible future dates.</a:t>
+              <a:t>Receipt date (17/09/2026) matches active tour trip_blr_mys_01 window.</a:t>
             </a:r>
           </a:p>
         </p:txBody>
@@ -11861,7 +12154,7 @@
         </p:nvSpPr>
         <p:spPr>
           <a:xfrm>
-            <a:off x="731520" y="6400800"/>
+            <a:off x="731520" y="6355080"/>
             <a:ext cx="10698480" cy="274320"/>
           </a:xfrm>
           <a:prstGeom prst="rect">
@@ -11884,7 +12177,7 @@
               </a:defRPr>
             </a:pPr>
             <a:r>
-              <a:t>CLAIMGUARD PRODUCT PITCH   |   SLIDE 08 OF 15</a:t>
+              <a:t>CLAIMGUARD PRODUCT PITCH   |   SLIDE 08 OF 15   |   APEX LOGISTICS INDIA PVT LTD</a:t>
             </a:r>
           </a:p>
         </p:txBody>
@@ -11958,8 +12251,8 @@
         </p:nvSpPr>
         <p:spPr>
           <a:xfrm>
-            <a:off x="731520" y="457200"/>
-            <a:ext cx="10698480" cy="365760"/>
+            <a:off x="731520" y="411480"/>
+            <a:ext cx="10698480" cy="320040"/>
           </a:xfrm>
           <a:prstGeom prst="rect">
             <a:avLst/>
@@ -11981,7 +12274,7 @@
               </a:defRPr>
             </a:pPr>
             <a:r>
-              <a:t>RISK ENGINE</a:t>
+              <a:t>RISK PRIORITIZATION &amp; REAL SCORES</a:t>
             </a:r>
           </a:p>
         </p:txBody>
@@ -11994,7 +12287,7 @@
         </p:nvSpPr>
         <p:spPr>
           <a:xfrm>
-            <a:off x="731520" y="822960"/>
+            <a:off x="731520" y="731520"/>
             <a:ext cx="10698480" cy="731520"/>
           </a:xfrm>
           <a:prstGeom prst="rect">
@@ -12009,7 +12302,7 @@
           <a:lstStyle/>
           <a:p>
             <a:pPr>
-              <a:defRPr sz="2800" b="1">
+              <a:defRPr sz="2600" b="1">
                 <a:solidFill>
                   <a:srgbClr val="0F172A"/>
                 </a:solidFill>
@@ -12038,8 +12331,8 @@
         </p:blipFill>
         <p:spPr>
           <a:xfrm>
-            <a:off x="731520" y="1645920"/>
-            <a:ext cx="5486400" cy="3062177"/>
+            <a:off x="731520" y="1691640"/>
+            <a:ext cx="5029200" cy="2806995"/>
           </a:xfrm>
           <a:prstGeom prst="rect">
             <a:avLst/>
@@ -12054,8 +12347,8 @@
         </p:nvSpPr>
         <p:spPr>
           <a:xfrm>
-            <a:off x="6492240" y="1645920"/>
-            <a:ext cx="4937760" cy="4389120"/>
+            <a:off x="6035040" y="1691640"/>
+            <a:ext cx="5394960" cy="4297680"/>
           </a:xfrm>
           <a:prstGeom prst="rect">
             <a:avLst/>
@@ -12069,29 +12362,29 @@
           <a:lstStyle/>
           <a:p>
             <a:pPr>
-              <a:defRPr sz="1200" b="1">
+              <a:defRPr sz="1100" b="1">
                 <a:solidFill>
                   <a:srgbClr val="F97316"/>
                 </a:solidFill>
               </a:defRPr>
             </a:pPr>
             <a:r>
-              <a:t>5 QUALIFIED AUTHENTICITY STATES</a:t>
+              <a:t>COMPARISON OF 2 REAL LIVE CLAIMS</a:t>
             </a:r>
           </a:p>
           <a:p>
             <a:pPr>
               <a:spcBef>
-                <a:spcPts val="800"/>
+                <a:spcPts val="1000"/>
               </a:spcBef>
-              <a:defRPr sz="1200" b="1">
+              <a:defRPr sz="1100" b="1">
                 <a:solidFill>
                   <a:srgbClr val="16A34A"/>
                 </a:solidFill>
               </a:defRPr>
             </a:pPr>
             <a:r>
-              <a:t>[VERIFIED]</a:t>
+              <a:t>[CLM-4401 &amp;bull; VERIFIED (SCORE: 8 / 100 &amp;bull; LOW)]</a:t>
             </a:r>
           </a:p>
           <a:p>
@@ -12099,29 +12392,29 @@
               <a:spcBef>
                 <a:spcPts val="200"/>
               </a:spcBef>
-              <a:defRPr sz="1000">
+              <a:defRPr sz="950">
                 <a:solidFill>
                   <a:srgbClr val="334155"/>
                 </a:solidFill>
               </a:defRPr>
             </a:pPr>
             <a:r>
-              <a:t>Valid GSTIN, clear OCR (&gt;90%), zero fraud signals. Score: 0-24.</a:t>
+              <a:t>Indian Oil Corp ₹1,850. Valid GSTIN, 0 fraud flags. Auto-approved or single-click clear.</a:t>
             </a:r>
           </a:p>
           <a:p>
             <a:pPr>
               <a:spcBef>
-                <a:spcPts val="800"/>
+                <a:spcPts val="1000"/>
               </a:spcBef>
-              <a:defRPr sz="1200" b="1">
-                <a:solidFill>
-                  <a:srgbClr val="2563EB"/>
-                </a:solidFill>
-              </a:defRPr>
-            </a:pPr>
-            <a:r>
-              <a:t>[LIKELY VALID]</a:t>
+              <a:defRPr sz="1100" b="1">
+                <a:solidFill>
+                  <a:srgbClr val="DC2626"/>
+                </a:solidFill>
+              </a:defRPr>
+            </a:pPr>
+            <a:r>
+              <a:t>[CLM-4471 &amp;bull; SUSPICIOUS (SCORE: 65 / 100 &amp;bull; HIGH)]</a:t>
             </a:r>
           </a:p>
           <a:p>
@@ -12129,29 +12422,29 @@
               <a:spcBef>
                 <a:spcPts val="200"/>
               </a:spcBef>
-              <a:defRPr sz="1000">
+              <a:defRPr sz="950">
                 <a:solidFill>
                   <a:srgbClr val="334155"/>
                 </a:solidFill>
               </a:defRPr>
             </a:pPr>
             <a:r>
-              <a:t>Minor warning, slight date deviation, valid math. Score: 0-24.</a:t>
+              <a:t>Duplicate hash (+40) + Anomaly spike (+20) + Policy cap (+5). Routed to Investigation.</a:t>
             </a:r>
           </a:p>
           <a:p>
             <a:pPr>
               <a:spcBef>
-                <a:spcPts val="800"/>
+                <a:spcPts val="1000"/>
               </a:spcBef>
-              <a:defRPr sz="1200" b="1">
-                <a:solidFill>
-                  <a:srgbClr val="D97706"/>
-                </a:solidFill>
-              </a:defRPr>
-            </a:pPr>
-            <a:r>
-              <a:t>[REVIEW REQUIRED]</a:t>
+              <a:defRPr sz="1100" b="1">
+                <a:solidFill>
+                  <a:srgbClr val="0F172A"/>
+                </a:solidFill>
+              </a:defRPr>
+            </a:pPr>
+            <a:r>
+              <a:t>[5 Standardized States]</a:t>
             </a:r>
           </a:p>
           <a:p>
@@ -12159,74 +12452,14 @@
               <a:spcBef>
                 <a:spcPts val="200"/>
               </a:spcBef>
-              <a:defRPr sz="1000">
+              <a:defRPr sz="950">
                 <a:solidFill>
                   <a:srgbClr val="334155"/>
                 </a:solidFill>
               </a:defRPr>
             </a:pPr>
             <a:r>
-              <a:t>Amount anomaly or policy limit breach needing sign-off. Score: 25-49.</a:t>
-            </a:r>
-          </a:p>
-          <a:p>
-            <a:pPr>
-              <a:spcBef>
-                <a:spcPts val="800"/>
-              </a:spcBef>
-              <a:defRPr sz="1200" b="1">
-                <a:solidFill>
-                  <a:srgbClr val="DC2626"/>
-                </a:solidFill>
-              </a:defRPr>
-            </a:pPr>
-            <a:r>
-              <a:t>[SUSPICIOUS]</a:t>
-            </a:r>
-          </a:p>
-          <a:p>
-            <a:pPr>
-              <a:spcBef>
-                <a:spcPts val="200"/>
-              </a:spcBef>
-              <a:defRPr sz="1000">
-                <a:solidFill>
-                  <a:srgbClr val="334155"/>
-                </a:solidFill>
-              </a:defRPr>
-            </a:pPr>
-            <a:r>
-              <a:t>Duplicate hash match or invalid tax checksum detected. Score: 50-74.</a:t>
-            </a:r>
-          </a:p>
-          <a:p>
-            <a:pPr>
-              <a:spcBef>
-                <a:spcPts val="800"/>
-              </a:spcBef>
-              <a:defRPr sz="1200" b="1">
-                <a:solidFill>
-                  <a:srgbClr val="64748B"/>
-                </a:solidFill>
-              </a:defRPr>
-            </a:pPr>
-            <a:r>
-              <a:t>[UNABLE TO VERIFY]</a:t>
-            </a:r>
-          </a:p>
-          <a:p>
-            <a:pPr>
-              <a:spcBef>
-                <a:spcPts val="200"/>
-              </a:spcBef>
-              <a:defRPr sz="1000">
-                <a:solidFill>
-                  <a:srgbClr val="334155"/>
-                </a:solidFill>
-              </a:defRPr>
-            </a:pPr>
-            <a:r>
-              <a:t>Blurred image, unreadable merchant, low OCR (&lt;70%). Requires retake.</a:t>
+              <a:t>VERIFIED (0–24), LIKELY VALID (0–24), REVIEW REQUIRED (25–49), SUSPICIOUS (50–74), UNABLE TO VERIFY (&lt;70% OCR).</a:t>
             </a:r>
           </a:p>
         </p:txBody>
@@ -12239,7 +12472,7 @@
         </p:nvSpPr>
         <p:spPr>
           <a:xfrm>
-            <a:off x="731520" y="6400800"/>
+            <a:off x="731520" y="6355080"/>
             <a:ext cx="10698480" cy="274320"/>
           </a:xfrm>
           <a:prstGeom prst="rect">
@@ -12262,7 +12495,7 @@
               </a:defRPr>
             </a:pPr>
             <a:r>
-              <a:t>CLAIMGUARD PRODUCT PITCH   |   SLIDE 09 OF 15</a:t>
+              <a:t>CLAIMGUARD PRODUCT PITCH   |   SLIDE 09 OF 15   |   APEX LOGISTICS INDIA PVT LTD</a:t>
             </a:r>
           </a:p>
         </p:txBody>

</xml_diff>